<commit_message>
Fix Turn and Talk slide layout in L1.2 (title above question, labelled countdown)
The chapter theme absolutely positions <h2> below the top of the slide,
so the discuss-directive's "Turn and Talk" heading rendered visually
under the prompt text. Promoted it to <h1> with a scoped per-slide
style reset so it sits on top, and labelled the timer "4:00 minutes"
for clarity. Countdown now also starts on load (not just on Bespoke
slide-activate) so it runs in non-presentation views too.

Co-Authored-By: Claude Sonnet 5 <noreply@anthropic.com>
</commit_message>
<xml_diff>
--- a/html/COMP-_L1.2_Lecture.pptx
+++ b/html/COMP-_L1.2_Lecture.pptx
@@ -884,7 +884,7 @@
       </p:grpSpPr>
       <p:sp>
         <p:nvSpPr>
-          <p:cNvPr id="161" name=""/>
+          <p:cNvPr id="162" name=""/>
           <p:cNvSpPr/>
           <p:nvPr/>
         </p:nvSpPr>
@@ -944,7 +944,7 @@
       </p:sp>
       <p:sp>
         <p:nvSpPr>
-          <p:cNvPr id="162" name=""/>
+          <p:cNvPr id="163" name=""/>
           <p:cNvSpPr/>
           <p:nvPr/>
         </p:nvSpPr>
@@ -1004,7 +1004,7 @@
       </p:sp>
       <p:sp>
         <p:nvSpPr>
-          <p:cNvPr id="163" name=""/>
+          <p:cNvPr id="164" name=""/>
           <p:cNvSpPr/>
           <p:nvPr/>
         </p:nvSpPr>
@@ -1064,7 +1064,7 @@
       </p:sp>
       <p:pic>
         <p:nvPicPr>
-          <p:cNvPr id="164" name="" descr=""/>
+          <p:cNvPr id="165" name="" descr=""/>
           <p:cNvPicPr/>
           <p:nvPr/>
         </p:nvPicPr>
@@ -1088,7 +1088,7 @@
       </p:pic>
       <p:sp>
         <p:nvSpPr>
-          <p:cNvPr id="165" name=""/>
+          <p:cNvPr id="166" name=""/>
           <p:cNvSpPr/>
           <p:nvPr/>
         </p:nvSpPr>
@@ -1216,7 +1216,7 @@
       </p:sp>
       <p:sp>
         <p:nvSpPr>
-          <p:cNvPr id="166" name=""/>
+          <p:cNvPr id="167" name=""/>
           <p:cNvSpPr txBox="1"/>
           <p:nvPr/>
         </p:nvSpPr>
@@ -1263,7 +1263,7 @@
       </p:sp>
       <p:sp>
         <p:nvSpPr>
-          <p:cNvPr id="167" name=""/>
+          <p:cNvPr id="168" name=""/>
           <p:cNvSpPr/>
           <p:nvPr/>
         </p:nvSpPr>
@@ -1391,7 +1391,7 @@
       </p:sp>
       <p:sp>
         <p:nvSpPr>
-          <p:cNvPr id="168" name=""/>
+          <p:cNvPr id="169" name=""/>
           <p:cNvSpPr txBox="1"/>
           <p:nvPr/>
         </p:nvSpPr>
@@ -1438,7 +1438,7 @@
       </p:sp>
       <p:sp>
         <p:nvSpPr>
-          <p:cNvPr id="169" name=""/>
+          <p:cNvPr id="170" name=""/>
           <p:cNvSpPr txBox="1"/>
           <p:nvPr/>
         </p:nvSpPr>
@@ -1485,7 +1485,7 @@
       </p:sp>
       <p:sp>
         <p:nvSpPr>
-          <p:cNvPr id="170" name=""/>
+          <p:cNvPr id="171" name=""/>
           <p:cNvSpPr/>
           <p:nvPr/>
         </p:nvSpPr>
@@ -1613,7 +1613,7 @@
       </p:sp>
       <p:sp>
         <p:nvSpPr>
-          <p:cNvPr id="171" name=""/>
+          <p:cNvPr id="172" name=""/>
           <p:cNvSpPr txBox="1"/>
           <p:nvPr/>
         </p:nvSpPr>
@@ -1660,7 +1660,7 @@
       </p:sp>
       <p:sp>
         <p:nvSpPr>
-          <p:cNvPr id="172" name=""/>
+          <p:cNvPr id="173" name=""/>
           <p:cNvSpPr txBox="1"/>
           <p:nvPr/>
         </p:nvSpPr>
@@ -1707,7 +1707,7 @@
       </p:sp>
       <p:sp>
         <p:nvSpPr>
-          <p:cNvPr id="173" name=""/>
+          <p:cNvPr id="174" name=""/>
           <p:cNvSpPr txBox="1"/>
           <p:nvPr/>
         </p:nvSpPr>
@@ -1754,7 +1754,7 @@
       </p:sp>
       <p:sp>
         <p:nvSpPr>
-          <p:cNvPr id="174" name=""/>
+          <p:cNvPr id="175" name=""/>
           <p:cNvSpPr/>
           <p:nvPr/>
         </p:nvSpPr>
@@ -1970,7 +1970,7 @@
       </p:sp>
       <p:sp>
         <p:nvSpPr>
-          <p:cNvPr id="175" name=""/>
+          <p:cNvPr id="176" name=""/>
           <p:cNvSpPr txBox="1"/>
           <p:nvPr/>
         </p:nvSpPr>
@@ -2017,7 +2017,7 @@
       </p:sp>
       <p:sp>
         <p:nvSpPr>
-          <p:cNvPr id="176" name=""/>
+          <p:cNvPr id="177" name=""/>
           <p:cNvSpPr txBox="1"/>
           <p:nvPr/>
         </p:nvSpPr>
@@ -2094,7 +2094,7 @@
       </p:grpSpPr>
       <p:sp>
         <p:nvSpPr>
-          <p:cNvPr id="177" name=""/>
+          <p:cNvPr id="178" name=""/>
           <p:cNvSpPr/>
           <p:nvPr/>
         </p:nvSpPr>
@@ -2154,7 +2154,7 @@
       </p:sp>
       <p:sp>
         <p:nvSpPr>
-          <p:cNvPr id="178" name=""/>
+          <p:cNvPr id="179" name=""/>
           <p:cNvSpPr/>
           <p:nvPr/>
         </p:nvSpPr>
@@ -2214,7 +2214,7 @@
       </p:sp>
       <p:sp>
         <p:nvSpPr>
-          <p:cNvPr id="179" name=""/>
+          <p:cNvPr id="180" name=""/>
           <p:cNvSpPr/>
           <p:nvPr/>
         </p:nvSpPr>
@@ -2274,7 +2274,7 @@
       </p:sp>
       <p:pic>
         <p:nvPicPr>
-          <p:cNvPr id="180" name="" descr=""/>
+          <p:cNvPr id="181" name="" descr=""/>
           <p:cNvPicPr/>
           <p:nvPr/>
         </p:nvPicPr>
@@ -2298,7 +2298,7 @@
       </p:pic>
       <p:sp>
         <p:nvSpPr>
-          <p:cNvPr id="181" name=""/>
+          <p:cNvPr id="182" name=""/>
           <p:cNvSpPr/>
           <p:nvPr/>
         </p:nvSpPr>
@@ -2426,7 +2426,7 @@
       </p:sp>
       <p:sp>
         <p:nvSpPr>
-          <p:cNvPr id="182" name=""/>
+          <p:cNvPr id="183" name=""/>
           <p:cNvSpPr txBox="1"/>
           <p:nvPr/>
         </p:nvSpPr>
@@ -2473,7 +2473,7 @@
       </p:sp>
       <p:sp>
         <p:nvSpPr>
-          <p:cNvPr id="183" name=""/>
+          <p:cNvPr id="184" name=""/>
           <p:cNvSpPr/>
           <p:nvPr/>
         </p:nvSpPr>
@@ -2601,7 +2601,7 @@
       </p:sp>
       <p:sp>
         <p:nvSpPr>
-          <p:cNvPr id="184" name=""/>
+          <p:cNvPr id="185" name=""/>
           <p:cNvSpPr txBox="1"/>
           <p:nvPr/>
         </p:nvSpPr>
@@ -2648,7 +2648,7 @@
       </p:sp>
       <p:sp>
         <p:nvSpPr>
-          <p:cNvPr id="185" name=""/>
+          <p:cNvPr id="186" name=""/>
           <p:cNvSpPr/>
           <p:nvPr/>
         </p:nvSpPr>
@@ -2776,7 +2776,7 @@
       </p:sp>
       <p:sp>
         <p:nvSpPr>
-          <p:cNvPr id="186" name=""/>
+          <p:cNvPr id="187" name=""/>
           <p:cNvSpPr txBox="1"/>
           <p:nvPr/>
         </p:nvSpPr>
@@ -2823,7 +2823,7 @@
       </p:sp>
       <p:sp>
         <p:nvSpPr>
-          <p:cNvPr id="187" name=""/>
+          <p:cNvPr id="188" name=""/>
           <p:cNvSpPr/>
           <p:nvPr/>
         </p:nvSpPr>
@@ -2951,7 +2951,7 @@
       </p:sp>
       <p:sp>
         <p:nvSpPr>
-          <p:cNvPr id="188" name=""/>
+          <p:cNvPr id="189" name=""/>
           <p:cNvSpPr txBox="1"/>
           <p:nvPr/>
         </p:nvSpPr>
@@ -2998,7 +2998,7 @@
       </p:sp>
       <p:sp>
         <p:nvSpPr>
-          <p:cNvPr id="189" name=""/>
+          <p:cNvPr id="190" name=""/>
           <p:cNvSpPr txBox="1"/>
           <p:nvPr/>
         </p:nvSpPr>
@@ -3045,7 +3045,7 @@
       </p:sp>
       <p:sp>
         <p:nvSpPr>
-          <p:cNvPr id="190" name=""/>
+          <p:cNvPr id="191" name=""/>
           <p:cNvSpPr txBox="1"/>
           <p:nvPr/>
         </p:nvSpPr>
@@ -3092,7 +3092,7 @@
       </p:sp>
       <p:sp>
         <p:nvSpPr>
-          <p:cNvPr id="191" name=""/>
+          <p:cNvPr id="192" name=""/>
           <p:cNvSpPr/>
           <p:nvPr/>
         </p:nvSpPr>
@@ -3308,7 +3308,7 @@
       </p:sp>
       <p:sp>
         <p:nvSpPr>
-          <p:cNvPr id="192" name=""/>
+          <p:cNvPr id="193" name=""/>
           <p:cNvSpPr txBox="1"/>
           <p:nvPr/>
         </p:nvSpPr>
@@ -3355,7 +3355,7 @@
       </p:sp>
       <p:sp>
         <p:nvSpPr>
-          <p:cNvPr id="193" name=""/>
+          <p:cNvPr id="194" name=""/>
           <p:cNvSpPr txBox="1"/>
           <p:nvPr/>
         </p:nvSpPr>
@@ -3432,7 +3432,7 @@
       </p:grpSpPr>
       <p:sp>
         <p:nvSpPr>
-          <p:cNvPr id="194" name=""/>
+          <p:cNvPr id="195" name=""/>
           <p:cNvSpPr/>
           <p:nvPr/>
         </p:nvSpPr>
@@ -3492,7 +3492,7 @@
       </p:sp>
       <p:sp>
         <p:nvSpPr>
-          <p:cNvPr id="195" name=""/>
+          <p:cNvPr id="196" name=""/>
           <p:cNvSpPr/>
           <p:nvPr/>
         </p:nvSpPr>
@@ -3552,7 +3552,7 @@
       </p:sp>
       <p:sp>
         <p:nvSpPr>
-          <p:cNvPr id="196" name=""/>
+          <p:cNvPr id="197" name=""/>
           <p:cNvSpPr/>
           <p:nvPr/>
         </p:nvSpPr>
@@ -3612,7 +3612,7 @@
       </p:sp>
       <p:pic>
         <p:nvPicPr>
-          <p:cNvPr id="197" name="" descr=""/>
+          <p:cNvPr id="198" name="" descr=""/>
           <p:cNvPicPr/>
           <p:nvPr/>
         </p:nvPicPr>
@@ -3636,7 +3636,7 @@
       </p:pic>
       <p:sp>
         <p:nvSpPr>
-          <p:cNvPr id="198" name=""/>
+          <p:cNvPr id="199" name=""/>
           <p:cNvSpPr/>
           <p:nvPr/>
         </p:nvSpPr>
@@ -3764,7 +3764,7 @@
       </p:sp>
       <p:sp>
         <p:nvSpPr>
-          <p:cNvPr id="199" name=""/>
+          <p:cNvPr id="200" name=""/>
           <p:cNvSpPr txBox="1"/>
           <p:nvPr/>
         </p:nvSpPr>
@@ -3811,7 +3811,7 @@
       </p:sp>
       <p:sp>
         <p:nvSpPr>
-          <p:cNvPr id="200" name=""/>
+          <p:cNvPr id="201" name=""/>
           <p:cNvSpPr/>
           <p:nvPr/>
         </p:nvSpPr>
@@ -3939,7 +3939,7 @@
       </p:sp>
       <p:sp>
         <p:nvSpPr>
-          <p:cNvPr id="201" name=""/>
+          <p:cNvPr id="202" name=""/>
           <p:cNvSpPr txBox="1"/>
           <p:nvPr/>
         </p:nvSpPr>
@@ -3986,7 +3986,7 @@
       </p:sp>
       <p:sp>
         <p:nvSpPr>
-          <p:cNvPr id="202" name=""/>
+          <p:cNvPr id="203" name=""/>
           <p:cNvSpPr/>
           <p:nvPr/>
         </p:nvSpPr>
@@ -4114,7 +4114,7 @@
       </p:sp>
       <p:sp>
         <p:nvSpPr>
-          <p:cNvPr id="203" name=""/>
+          <p:cNvPr id="204" name=""/>
           <p:cNvSpPr txBox="1"/>
           <p:nvPr/>
         </p:nvSpPr>
@@ -4161,7 +4161,7 @@
       </p:sp>
       <p:sp>
         <p:nvSpPr>
-          <p:cNvPr id="204" name=""/>
+          <p:cNvPr id="205" name=""/>
           <p:cNvSpPr txBox="1"/>
           <p:nvPr/>
         </p:nvSpPr>
@@ -4208,7 +4208,7 @@
       </p:sp>
       <p:sp>
         <p:nvSpPr>
-          <p:cNvPr id="205" name=""/>
+          <p:cNvPr id="206" name=""/>
           <p:cNvSpPr txBox="1"/>
           <p:nvPr/>
         </p:nvSpPr>
@@ -4255,7 +4255,7 @@
       </p:sp>
       <p:sp>
         <p:nvSpPr>
-          <p:cNvPr id="206" name=""/>
+          <p:cNvPr id="207" name=""/>
           <p:cNvSpPr/>
           <p:nvPr/>
         </p:nvSpPr>
@@ -4471,7 +4471,7 @@
       </p:sp>
       <p:sp>
         <p:nvSpPr>
-          <p:cNvPr id="207" name=""/>
+          <p:cNvPr id="208" name=""/>
           <p:cNvSpPr txBox="1"/>
           <p:nvPr/>
         </p:nvSpPr>
@@ -4518,7 +4518,7 @@
       </p:sp>
       <p:sp>
         <p:nvSpPr>
-          <p:cNvPr id="208" name=""/>
+          <p:cNvPr id="209" name=""/>
           <p:cNvSpPr txBox="1"/>
           <p:nvPr/>
         </p:nvSpPr>
@@ -4595,7 +4595,7 @@
       </p:grpSpPr>
       <p:sp>
         <p:nvSpPr>
-          <p:cNvPr id="209" name=""/>
+          <p:cNvPr id="210" name=""/>
           <p:cNvSpPr/>
           <p:nvPr/>
         </p:nvSpPr>
@@ -4655,7 +4655,7 @@
       </p:sp>
       <p:sp>
         <p:nvSpPr>
-          <p:cNvPr id="210" name=""/>
+          <p:cNvPr id="211" name=""/>
           <p:cNvSpPr/>
           <p:nvPr/>
         </p:nvSpPr>
@@ -4715,7 +4715,7 @@
       </p:sp>
       <p:sp>
         <p:nvSpPr>
-          <p:cNvPr id="211" name=""/>
+          <p:cNvPr id="212" name=""/>
           <p:cNvSpPr/>
           <p:nvPr/>
         </p:nvSpPr>
@@ -4775,7 +4775,7 @@
       </p:sp>
       <p:pic>
         <p:nvPicPr>
-          <p:cNvPr id="212" name="" descr=""/>
+          <p:cNvPr id="213" name="" descr=""/>
           <p:cNvPicPr/>
           <p:nvPr/>
         </p:nvPicPr>
@@ -4799,7 +4799,7 @@
       </p:pic>
       <p:sp>
         <p:nvSpPr>
-          <p:cNvPr id="213" name=""/>
+          <p:cNvPr id="214" name=""/>
           <p:cNvSpPr/>
           <p:nvPr/>
         </p:nvSpPr>
@@ -4927,7 +4927,7 @@
       </p:sp>
       <p:sp>
         <p:nvSpPr>
-          <p:cNvPr id="214" name=""/>
+          <p:cNvPr id="215" name=""/>
           <p:cNvSpPr txBox="1"/>
           <p:nvPr/>
         </p:nvSpPr>
@@ -4974,7 +4974,7 @@
       </p:sp>
       <p:sp>
         <p:nvSpPr>
-          <p:cNvPr id="215" name=""/>
+          <p:cNvPr id="216" name=""/>
           <p:cNvSpPr txBox="1"/>
           <p:nvPr/>
         </p:nvSpPr>
@@ -5033,7 +5033,7 @@
       </p:sp>
       <p:sp>
         <p:nvSpPr>
-          <p:cNvPr id="216" name=""/>
+          <p:cNvPr id="217" name=""/>
           <p:cNvSpPr/>
           <p:nvPr/>
         </p:nvSpPr>
@@ -5161,7 +5161,7 @@
       </p:sp>
       <p:sp>
         <p:nvSpPr>
-          <p:cNvPr id="217" name=""/>
+          <p:cNvPr id="218" name=""/>
           <p:cNvSpPr txBox="1"/>
           <p:nvPr/>
         </p:nvSpPr>
@@ -5208,7 +5208,7 @@
       </p:sp>
       <p:sp>
         <p:nvSpPr>
-          <p:cNvPr id="218" name=""/>
+          <p:cNvPr id="219" name=""/>
           <p:cNvSpPr/>
           <p:nvPr/>
         </p:nvSpPr>
@@ -5336,7 +5336,7 @@
       </p:sp>
       <p:sp>
         <p:nvSpPr>
-          <p:cNvPr id="219" name=""/>
+          <p:cNvPr id="220" name=""/>
           <p:cNvSpPr txBox="1"/>
           <p:nvPr/>
         </p:nvSpPr>
@@ -5383,7 +5383,7 @@
       </p:sp>
       <p:sp>
         <p:nvSpPr>
-          <p:cNvPr id="220" name=""/>
+          <p:cNvPr id="221" name=""/>
           <p:cNvSpPr/>
           <p:nvPr/>
         </p:nvSpPr>
@@ -5511,7 +5511,7 @@
       </p:sp>
       <p:sp>
         <p:nvSpPr>
-          <p:cNvPr id="221" name=""/>
+          <p:cNvPr id="222" name=""/>
           <p:cNvSpPr txBox="1"/>
           <p:nvPr/>
         </p:nvSpPr>
@@ -5558,7 +5558,7 @@
       </p:sp>
       <p:sp>
         <p:nvSpPr>
-          <p:cNvPr id="222" name=""/>
+          <p:cNvPr id="223" name=""/>
           <p:cNvSpPr txBox="1"/>
           <p:nvPr/>
         </p:nvSpPr>
@@ -5605,7 +5605,7 @@
       </p:sp>
       <p:sp>
         <p:nvSpPr>
-          <p:cNvPr id="223" name=""/>
+          <p:cNvPr id="224" name=""/>
           <p:cNvSpPr txBox="1"/>
           <p:nvPr/>
         </p:nvSpPr>
@@ -5652,7 +5652,7 @@
       </p:sp>
       <p:sp>
         <p:nvSpPr>
-          <p:cNvPr id="224" name=""/>
+          <p:cNvPr id="225" name=""/>
           <p:cNvSpPr txBox="1"/>
           <p:nvPr/>
         </p:nvSpPr>
@@ -5699,7 +5699,7 @@
       </p:sp>
       <p:sp>
         <p:nvSpPr>
-          <p:cNvPr id="225" name=""/>
+          <p:cNvPr id="226" name=""/>
           <p:cNvSpPr txBox="1"/>
           <p:nvPr/>
         </p:nvSpPr>
@@ -5746,7 +5746,7 @@
       </p:sp>
       <p:sp>
         <p:nvSpPr>
-          <p:cNvPr id="226" name=""/>
+          <p:cNvPr id="227" name=""/>
           <p:cNvSpPr/>
           <p:nvPr/>
         </p:nvSpPr>
@@ -5966,7 +5966,7 @@
       </p:sp>
       <p:sp>
         <p:nvSpPr>
-          <p:cNvPr id="227" name=""/>
+          <p:cNvPr id="228" name=""/>
           <p:cNvSpPr/>
           <p:nvPr/>
         </p:nvSpPr>
@@ -6185,7 +6185,7 @@
       </p:sp>
       <p:sp>
         <p:nvSpPr>
-          <p:cNvPr id="228" name=""/>
+          <p:cNvPr id="229" name=""/>
           <p:cNvSpPr txBox="1"/>
           <p:nvPr/>
         </p:nvSpPr>
@@ -6232,7 +6232,7 @@
       </p:sp>
       <p:sp>
         <p:nvSpPr>
-          <p:cNvPr id="229" name=""/>
+          <p:cNvPr id="230" name=""/>
           <p:cNvSpPr txBox="1"/>
           <p:nvPr/>
         </p:nvSpPr>
@@ -6279,7 +6279,7 @@
       </p:sp>
       <p:sp>
         <p:nvSpPr>
-          <p:cNvPr id="230" name=""/>
+          <p:cNvPr id="231" name=""/>
           <p:cNvSpPr txBox="1"/>
           <p:nvPr/>
         </p:nvSpPr>
@@ -6326,7 +6326,7 @@
       </p:sp>
       <p:sp>
         <p:nvSpPr>
-          <p:cNvPr id="231" name=""/>
+          <p:cNvPr id="232" name=""/>
           <p:cNvSpPr txBox="1"/>
           <p:nvPr/>
         </p:nvSpPr>
@@ -6373,7 +6373,7 @@
       </p:sp>
       <p:sp>
         <p:nvSpPr>
-          <p:cNvPr id="232" name=""/>
+          <p:cNvPr id="233" name=""/>
           <p:cNvSpPr txBox="1"/>
           <p:nvPr/>
         </p:nvSpPr>
@@ -6420,7 +6420,7 @@
       </p:sp>
       <p:sp>
         <p:nvSpPr>
-          <p:cNvPr id="233" name=""/>
+          <p:cNvPr id="234" name=""/>
           <p:cNvSpPr txBox="1"/>
           <p:nvPr/>
         </p:nvSpPr>
@@ -6467,7 +6467,7 @@
       </p:sp>
       <p:sp>
         <p:nvSpPr>
-          <p:cNvPr id="234" name=""/>
+          <p:cNvPr id="235" name=""/>
           <p:cNvSpPr txBox="1"/>
           <p:nvPr/>
         </p:nvSpPr>
@@ -6514,7 +6514,7 @@
       </p:sp>
       <p:sp>
         <p:nvSpPr>
-          <p:cNvPr id="235" name=""/>
+          <p:cNvPr id="236" name=""/>
           <p:cNvSpPr txBox="1"/>
           <p:nvPr/>
         </p:nvSpPr>
@@ -6561,7 +6561,7 @@
       </p:sp>
       <p:sp>
         <p:nvSpPr>
-          <p:cNvPr id="236" name=""/>
+          <p:cNvPr id="237" name=""/>
           <p:cNvSpPr txBox="1"/>
           <p:nvPr/>
         </p:nvSpPr>
@@ -6608,7 +6608,7 @@
       </p:sp>
       <p:sp>
         <p:nvSpPr>
-          <p:cNvPr id="237" name=""/>
+          <p:cNvPr id="238" name=""/>
           <p:cNvSpPr/>
           <p:nvPr/>
         </p:nvSpPr>
@@ -6824,7 +6824,7 @@
       </p:sp>
       <p:sp>
         <p:nvSpPr>
-          <p:cNvPr id="238" name=""/>
+          <p:cNvPr id="239" name=""/>
           <p:cNvSpPr txBox="1"/>
           <p:nvPr/>
         </p:nvSpPr>
@@ -6871,7 +6871,7 @@
       </p:sp>
       <p:sp>
         <p:nvSpPr>
-          <p:cNvPr id="239" name=""/>
+          <p:cNvPr id="240" name=""/>
           <p:cNvSpPr txBox="1"/>
           <p:nvPr/>
         </p:nvSpPr>
@@ -6948,7 +6948,7 @@
       </p:grpSpPr>
       <p:sp>
         <p:nvSpPr>
-          <p:cNvPr id="240" name=""/>
+          <p:cNvPr id="241" name=""/>
           <p:cNvSpPr/>
           <p:nvPr/>
         </p:nvSpPr>
@@ -7008,7 +7008,7 @@
       </p:sp>
       <p:sp>
         <p:nvSpPr>
-          <p:cNvPr id="241" name=""/>
+          <p:cNvPr id="242" name=""/>
           <p:cNvSpPr/>
           <p:nvPr/>
         </p:nvSpPr>
@@ -7068,7 +7068,7 @@
       </p:sp>
       <p:sp>
         <p:nvSpPr>
-          <p:cNvPr id="242" name=""/>
+          <p:cNvPr id="243" name=""/>
           <p:cNvSpPr/>
           <p:nvPr/>
         </p:nvSpPr>
@@ -7128,7 +7128,7 @@
       </p:sp>
       <p:pic>
         <p:nvPicPr>
-          <p:cNvPr id="243" name="" descr=""/>
+          <p:cNvPr id="244" name="" descr=""/>
           <p:cNvPicPr/>
           <p:nvPr/>
         </p:nvPicPr>
@@ -7152,7 +7152,7 @@
       </p:pic>
       <p:sp>
         <p:nvSpPr>
-          <p:cNvPr id="244" name=""/>
+          <p:cNvPr id="245" name=""/>
           <p:cNvSpPr/>
           <p:nvPr/>
         </p:nvSpPr>
@@ -7212,7 +7212,7 @@
       </p:sp>
       <p:pic>
         <p:nvPicPr>
-          <p:cNvPr id="245" name="" descr=""/>
+          <p:cNvPr id="246" name="" descr=""/>
           <p:cNvPicPr/>
           <p:nvPr/>
         </p:nvPicPr>
@@ -7236,7 +7236,7 @@
       </p:pic>
       <p:sp>
         <p:nvSpPr>
-          <p:cNvPr id="246" name=""/>
+          <p:cNvPr id="247" name=""/>
           <p:cNvSpPr txBox="1"/>
           <p:nvPr/>
         </p:nvSpPr>
@@ -7283,7 +7283,7 @@
       </p:sp>
       <p:sp>
         <p:nvSpPr>
-          <p:cNvPr id="247" name=""/>
+          <p:cNvPr id="248" name=""/>
           <p:cNvSpPr txBox="1"/>
           <p:nvPr/>
         </p:nvSpPr>
@@ -7330,7 +7330,7 @@
       </p:sp>
       <p:sp>
         <p:nvSpPr>
-          <p:cNvPr id="248" name=""/>
+          <p:cNvPr id="249" name=""/>
           <p:cNvSpPr/>
           <p:nvPr/>
         </p:nvSpPr>
@@ -7546,7 +7546,7 @@
       </p:sp>
       <p:sp>
         <p:nvSpPr>
-          <p:cNvPr id="249" name=""/>
+          <p:cNvPr id="250" name=""/>
           <p:cNvSpPr txBox="1"/>
           <p:nvPr/>
         </p:nvSpPr>
@@ -7593,7 +7593,7 @@
       </p:sp>
       <p:sp>
         <p:nvSpPr>
-          <p:cNvPr id="250" name=""/>
+          <p:cNvPr id="251" name=""/>
           <p:cNvSpPr txBox="1"/>
           <p:nvPr/>
         </p:nvSpPr>
@@ -7670,7 +7670,7 @@
       </p:grpSpPr>
       <p:sp>
         <p:nvSpPr>
-          <p:cNvPr id="251" name=""/>
+          <p:cNvPr id="252" name=""/>
           <p:cNvSpPr/>
           <p:nvPr/>
         </p:nvSpPr>
@@ -7730,7 +7730,7 @@
       </p:sp>
       <p:sp>
         <p:nvSpPr>
-          <p:cNvPr id="252" name=""/>
+          <p:cNvPr id="253" name=""/>
           <p:cNvSpPr/>
           <p:nvPr/>
         </p:nvSpPr>
@@ -7790,7 +7790,7 @@
       </p:sp>
       <p:sp>
         <p:nvSpPr>
-          <p:cNvPr id="253" name=""/>
+          <p:cNvPr id="254" name=""/>
           <p:cNvSpPr/>
           <p:nvPr/>
         </p:nvSpPr>
@@ -7850,7 +7850,7 @@
       </p:sp>
       <p:pic>
         <p:nvPicPr>
-          <p:cNvPr id="254" name="" descr=""/>
+          <p:cNvPr id="255" name="" descr=""/>
           <p:cNvPicPr/>
           <p:nvPr/>
         </p:nvPicPr>
@@ -7874,7 +7874,7 @@
       </p:pic>
       <p:sp>
         <p:nvSpPr>
-          <p:cNvPr id="255" name=""/>
+          <p:cNvPr id="256" name=""/>
           <p:cNvSpPr txBox="1"/>
           <p:nvPr/>
         </p:nvSpPr>
@@ -7921,7 +7921,7 @@
       </p:sp>
       <p:sp>
         <p:nvSpPr>
-          <p:cNvPr id="256" name=""/>
+          <p:cNvPr id="257" name=""/>
           <p:cNvSpPr txBox="1"/>
           <p:nvPr/>
         </p:nvSpPr>
@@ -7968,7 +7968,7 @@
       </p:sp>
       <p:sp>
         <p:nvSpPr>
-          <p:cNvPr id="257" name=""/>
+          <p:cNvPr id="258" name=""/>
           <p:cNvSpPr/>
           <p:nvPr/>
         </p:nvSpPr>
@@ -8188,7 +8188,7 @@
       </p:sp>
       <p:sp>
         <p:nvSpPr>
-          <p:cNvPr id="258" name=""/>
+          <p:cNvPr id="259" name=""/>
           <p:cNvSpPr/>
           <p:nvPr/>
         </p:nvSpPr>
@@ -8407,7 +8407,7 @@
       </p:sp>
       <p:sp>
         <p:nvSpPr>
-          <p:cNvPr id="259" name=""/>
+          <p:cNvPr id="260" name=""/>
           <p:cNvSpPr txBox="1"/>
           <p:nvPr/>
         </p:nvSpPr>
@@ -8454,7 +8454,7 @@
       </p:sp>
       <p:sp>
         <p:nvSpPr>
-          <p:cNvPr id="260" name=""/>
+          <p:cNvPr id="261" name=""/>
           <p:cNvSpPr/>
           <p:nvPr/>
         </p:nvSpPr>
@@ -8582,7 +8582,7 @@
       </p:sp>
       <p:sp>
         <p:nvSpPr>
-          <p:cNvPr id="261" name=""/>
+          <p:cNvPr id="262" name=""/>
           <p:cNvSpPr txBox="1"/>
           <p:nvPr/>
         </p:nvSpPr>
@@ -8629,7 +8629,7 @@
       </p:sp>
       <p:sp>
         <p:nvSpPr>
-          <p:cNvPr id="262" name=""/>
+          <p:cNvPr id="263" name=""/>
           <p:cNvSpPr txBox="1"/>
           <p:nvPr/>
         </p:nvSpPr>
@@ -8676,7 +8676,7 @@
       </p:sp>
       <p:sp>
         <p:nvSpPr>
-          <p:cNvPr id="263" name=""/>
+          <p:cNvPr id="264" name=""/>
           <p:cNvSpPr/>
           <p:nvPr/>
         </p:nvSpPr>
@@ -8804,7 +8804,7 @@
       </p:sp>
       <p:sp>
         <p:nvSpPr>
-          <p:cNvPr id="264" name=""/>
+          <p:cNvPr id="265" name=""/>
           <p:cNvSpPr txBox="1"/>
           <p:nvPr/>
         </p:nvSpPr>
@@ -8851,7 +8851,7 @@
       </p:sp>
       <p:sp>
         <p:nvSpPr>
-          <p:cNvPr id="265" name=""/>
+          <p:cNvPr id="266" name=""/>
           <p:cNvSpPr/>
           <p:nvPr/>
         </p:nvSpPr>
@@ -8979,7 +8979,7 @@
       </p:sp>
       <p:sp>
         <p:nvSpPr>
-          <p:cNvPr id="266" name=""/>
+          <p:cNvPr id="267" name=""/>
           <p:cNvSpPr txBox="1"/>
           <p:nvPr/>
         </p:nvSpPr>
@@ -9026,7 +9026,7 @@
       </p:sp>
       <p:sp>
         <p:nvSpPr>
-          <p:cNvPr id="267" name=""/>
+          <p:cNvPr id="268" name=""/>
           <p:cNvSpPr/>
           <p:nvPr/>
         </p:nvSpPr>
@@ -9246,7 +9246,7 @@
       </p:sp>
       <p:sp>
         <p:nvSpPr>
-          <p:cNvPr id="268" name=""/>
+          <p:cNvPr id="269" name=""/>
           <p:cNvSpPr/>
           <p:nvPr/>
         </p:nvSpPr>
@@ -9465,7 +9465,7 @@
       </p:sp>
       <p:sp>
         <p:nvSpPr>
-          <p:cNvPr id="269" name=""/>
+          <p:cNvPr id="270" name=""/>
           <p:cNvSpPr txBox="1"/>
           <p:nvPr/>
         </p:nvSpPr>
@@ -9512,7 +9512,7 @@
       </p:sp>
       <p:sp>
         <p:nvSpPr>
-          <p:cNvPr id="270" name=""/>
+          <p:cNvPr id="271" name=""/>
           <p:cNvSpPr/>
           <p:nvPr/>
         </p:nvSpPr>
@@ -9640,7 +9640,7 @@
       </p:sp>
       <p:sp>
         <p:nvSpPr>
-          <p:cNvPr id="271" name=""/>
+          <p:cNvPr id="272" name=""/>
           <p:cNvSpPr txBox="1"/>
           <p:nvPr/>
         </p:nvSpPr>
@@ -9687,7 +9687,7 @@
       </p:sp>
       <p:sp>
         <p:nvSpPr>
-          <p:cNvPr id="272" name=""/>
+          <p:cNvPr id="273" name=""/>
           <p:cNvSpPr/>
           <p:nvPr/>
         </p:nvSpPr>
@@ -9815,7 +9815,7 @@
       </p:sp>
       <p:sp>
         <p:nvSpPr>
-          <p:cNvPr id="273" name=""/>
+          <p:cNvPr id="274" name=""/>
           <p:cNvSpPr txBox="1"/>
           <p:nvPr/>
         </p:nvSpPr>
@@ -9862,7 +9862,7 @@
       </p:sp>
       <p:sp>
         <p:nvSpPr>
-          <p:cNvPr id="274" name=""/>
+          <p:cNvPr id="275" name=""/>
           <p:cNvSpPr/>
           <p:nvPr/>
         </p:nvSpPr>
@@ -9990,7 +9990,7 @@
       </p:sp>
       <p:sp>
         <p:nvSpPr>
-          <p:cNvPr id="275" name=""/>
+          <p:cNvPr id="276" name=""/>
           <p:cNvSpPr txBox="1"/>
           <p:nvPr/>
         </p:nvSpPr>
@@ -10037,7 +10037,7 @@
       </p:sp>
       <p:sp>
         <p:nvSpPr>
-          <p:cNvPr id="276" name=""/>
+          <p:cNvPr id="277" name=""/>
           <p:cNvSpPr txBox="1"/>
           <p:nvPr/>
         </p:nvSpPr>
@@ -10084,7 +10084,7 @@
       </p:sp>
       <p:sp>
         <p:nvSpPr>
-          <p:cNvPr id="277" name=""/>
+          <p:cNvPr id="278" name=""/>
           <p:cNvSpPr/>
           <p:nvPr/>
         </p:nvSpPr>
@@ -10212,7 +10212,7 @@
       </p:sp>
       <p:sp>
         <p:nvSpPr>
-          <p:cNvPr id="278" name=""/>
+          <p:cNvPr id="279" name=""/>
           <p:cNvSpPr txBox="1"/>
           <p:nvPr/>
         </p:nvSpPr>
@@ -10259,7 +10259,7 @@
       </p:sp>
       <p:sp>
         <p:nvSpPr>
-          <p:cNvPr id="279" name=""/>
+          <p:cNvPr id="280" name=""/>
           <p:cNvSpPr txBox="1"/>
           <p:nvPr/>
         </p:nvSpPr>
@@ -10306,7 +10306,7 @@
       </p:sp>
       <p:sp>
         <p:nvSpPr>
-          <p:cNvPr id="280" name=""/>
+          <p:cNvPr id="281" name=""/>
           <p:cNvSpPr/>
           <p:nvPr/>
         </p:nvSpPr>
@@ -10526,7 +10526,7 @@
       </p:sp>
       <p:sp>
         <p:nvSpPr>
-          <p:cNvPr id="281" name=""/>
+          <p:cNvPr id="282" name=""/>
           <p:cNvSpPr/>
           <p:nvPr/>
         </p:nvSpPr>
@@ -10745,7 +10745,7 @@
       </p:sp>
       <p:sp>
         <p:nvSpPr>
-          <p:cNvPr id="282" name=""/>
+          <p:cNvPr id="283" name=""/>
           <p:cNvSpPr txBox="1"/>
           <p:nvPr/>
         </p:nvSpPr>
@@ -10792,7 +10792,7 @@
       </p:sp>
       <p:sp>
         <p:nvSpPr>
-          <p:cNvPr id="283" name=""/>
+          <p:cNvPr id="284" name=""/>
           <p:cNvSpPr/>
           <p:nvPr/>
         </p:nvSpPr>
@@ -10920,7 +10920,7 @@
       </p:sp>
       <p:sp>
         <p:nvSpPr>
-          <p:cNvPr id="284" name=""/>
+          <p:cNvPr id="285" name=""/>
           <p:cNvSpPr txBox="1"/>
           <p:nvPr/>
         </p:nvSpPr>
@@ -10967,7 +10967,7 @@
       </p:sp>
       <p:sp>
         <p:nvSpPr>
-          <p:cNvPr id="285" name=""/>
+          <p:cNvPr id="286" name=""/>
           <p:cNvSpPr/>
           <p:nvPr/>
         </p:nvSpPr>
@@ -11095,7 +11095,7 @@
       </p:sp>
       <p:sp>
         <p:nvSpPr>
-          <p:cNvPr id="286" name=""/>
+          <p:cNvPr id="287" name=""/>
           <p:cNvSpPr txBox="1"/>
           <p:nvPr/>
         </p:nvSpPr>
@@ -11142,7 +11142,7 @@
       </p:sp>
       <p:sp>
         <p:nvSpPr>
-          <p:cNvPr id="287" name=""/>
+          <p:cNvPr id="288" name=""/>
           <p:cNvSpPr/>
           <p:nvPr/>
         </p:nvSpPr>
@@ -11270,7 +11270,7 @@
       </p:sp>
       <p:sp>
         <p:nvSpPr>
-          <p:cNvPr id="288" name=""/>
+          <p:cNvPr id="289" name=""/>
           <p:cNvSpPr txBox="1"/>
           <p:nvPr/>
         </p:nvSpPr>
@@ -11317,7 +11317,7 @@
       </p:sp>
       <p:sp>
         <p:nvSpPr>
-          <p:cNvPr id="289" name=""/>
+          <p:cNvPr id="290" name=""/>
           <p:cNvSpPr/>
           <p:nvPr/>
         </p:nvSpPr>
@@ -11445,7 +11445,7 @@
       </p:sp>
       <p:sp>
         <p:nvSpPr>
-          <p:cNvPr id="290" name=""/>
+          <p:cNvPr id="291" name=""/>
           <p:cNvSpPr txBox="1"/>
           <p:nvPr/>
         </p:nvSpPr>
@@ -11492,7 +11492,7 @@
       </p:sp>
       <p:sp>
         <p:nvSpPr>
-          <p:cNvPr id="291" name=""/>
+          <p:cNvPr id="292" name=""/>
           <p:cNvSpPr txBox="1"/>
           <p:nvPr/>
         </p:nvSpPr>
@@ -11539,7 +11539,7 @@
       </p:sp>
       <p:sp>
         <p:nvSpPr>
-          <p:cNvPr id="292" name=""/>
+          <p:cNvPr id="293" name=""/>
           <p:cNvSpPr/>
           <p:nvPr/>
         </p:nvSpPr>
@@ -11755,7 +11755,7 @@
       </p:sp>
       <p:sp>
         <p:nvSpPr>
-          <p:cNvPr id="293" name=""/>
+          <p:cNvPr id="294" name=""/>
           <p:cNvSpPr txBox="1"/>
           <p:nvPr/>
         </p:nvSpPr>
@@ -11802,7 +11802,7 @@
       </p:sp>
       <p:sp>
         <p:nvSpPr>
-          <p:cNvPr id="294" name=""/>
+          <p:cNvPr id="295" name=""/>
           <p:cNvSpPr txBox="1"/>
           <p:nvPr/>
         </p:nvSpPr>
@@ -11879,7 +11879,7 @@
       </p:grpSpPr>
       <p:sp>
         <p:nvSpPr>
-          <p:cNvPr id="295" name=""/>
+          <p:cNvPr id="296" name=""/>
           <p:cNvSpPr/>
           <p:nvPr/>
         </p:nvSpPr>
@@ -11939,7 +11939,7 @@
       </p:sp>
       <p:sp>
         <p:nvSpPr>
-          <p:cNvPr id="296" name=""/>
+          <p:cNvPr id="297" name=""/>
           <p:cNvSpPr/>
           <p:nvPr/>
         </p:nvSpPr>
@@ -11999,7 +11999,7 @@
       </p:sp>
       <p:sp>
         <p:nvSpPr>
-          <p:cNvPr id="297" name=""/>
+          <p:cNvPr id="298" name=""/>
           <p:cNvSpPr/>
           <p:nvPr/>
         </p:nvSpPr>
@@ -12059,7 +12059,7 @@
       </p:sp>
       <p:pic>
         <p:nvPicPr>
-          <p:cNvPr id="298" name="" descr=""/>
+          <p:cNvPr id="299" name="" descr=""/>
           <p:cNvPicPr/>
           <p:nvPr/>
         </p:nvPicPr>
@@ -12083,7 +12083,7 @@
       </p:pic>
       <p:sp>
         <p:nvSpPr>
-          <p:cNvPr id="299" name=""/>
+          <p:cNvPr id="300" name=""/>
           <p:cNvSpPr/>
           <p:nvPr/>
         </p:nvSpPr>
@@ -12211,7 +12211,7 @@
       </p:sp>
       <p:sp>
         <p:nvSpPr>
-          <p:cNvPr id="300" name=""/>
+          <p:cNvPr id="301" name=""/>
           <p:cNvSpPr txBox="1"/>
           <p:nvPr/>
         </p:nvSpPr>
@@ -12258,7 +12258,7 @@
       </p:sp>
       <p:sp>
         <p:nvSpPr>
-          <p:cNvPr id="301" name=""/>
+          <p:cNvPr id="302" name=""/>
           <p:cNvSpPr/>
           <p:nvPr/>
         </p:nvSpPr>
@@ -12386,7 +12386,7 @@
       </p:sp>
       <p:sp>
         <p:nvSpPr>
-          <p:cNvPr id="302" name=""/>
+          <p:cNvPr id="303" name=""/>
           <p:cNvSpPr txBox="1"/>
           <p:nvPr/>
         </p:nvSpPr>
@@ -12433,7 +12433,7 @@
       </p:sp>
       <p:sp>
         <p:nvSpPr>
-          <p:cNvPr id="303" name=""/>
+          <p:cNvPr id="304" name=""/>
           <p:cNvSpPr/>
           <p:nvPr/>
         </p:nvSpPr>
@@ -12561,7 +12561,7 @@
       </p:sp>
       <p:sp>
         <p:nvSpPr>
-          <p:cNvPr id="304" name=""/>
+          <p:cNvPr id="305" name=""/>
           <p:cNvSpPr txBox="1"/>
           <p:nvPr/>
         </p:nvSpPr>
@@ -12608,7 +12608,7 @@
       </p:sp>
       <p:sp>
         <p:nvSpPr>
-          <p:cNvPr id="305" name=""/>
+          <p:cNvPr id="306" name=""/>
           <p:cNvSpPr/>
           <p:nvPr/>
         </p:nvSpPr>
@@ -12736,7 +12736,7 @@
       </p:sp>
       <p:sp>
         <p:nvSpPr>
-          <p:cNvPr id="306" name=""/>
+          <p:cNvPr id="307" name=""/>
           <p:cNvSpPr txBox="1"/>
           <p:nvPr/>
         </p:nvSpPr>
@@ -12783,7 +12783,7 @@
       </p:sp>
       <p:sp>
         <p:nvSpPr>
-          <p:cNvPr id="307" name=""/>
+          <p:cNvPr id="308" name=""/>
           <p:cNvSpPr txBox="1"/>
           <p:nvPr/>
         </p:nvSpPr>
@@ -12830,7 +12830,7 @@
       </p:sp>
       <p:sp>
         <p:nvSpPr>
-          <p:cNvPr id="308" name=""/>
+          <p:cNvPr id="309" name=""/>
           <p:cNvSpPr txBox="1"/>
           <p:nvPr/>
         </p:nvSpPr>
@@ -12877,7 +12877,7 @@
       </p:sp>
       <p:sp>
         <p:nvSpPr>
-          <p:cNvPr id="309" name=""/>
+          <p:cNvPr id="310" name=""/>
           <p:cNvSpPr/>
           <p:nvPr/>
         </p:nvSpPr>
@@ -13097,7 +13097,7 @@
       </p:sp>
       <p:sp>
         <p:nvSpPr>
-          <p:cNvPr id="310" name=""/>
+          <p:cNvPr id="311" name=""/>
           <p:cNvSpPr/>
           <p:nvPr/>
         </p:nvSpPr>
@@ -13316,7 +13316,7 @@
       </p:sp>
       <p:sp>
         <p:nvSpPr>
-          <p:cNvPr id="311" name=""/>
+          <p:cNvPr id="312" name=""/>
           <p:cNvSpPr txBox="1"/>
           <p:nvPr/>
         </p:nvSpPr>
@@ -13363,7 +13363,7 @@
       </p:sp>
       <p:sp>
         <p:nvSpPr>
-          <p:cNvPr id="312" name=""/>
+          <p:cNvPr id="313" name=""/>
           <p:cNvSpPr txBox="1"/>
           <p:nvPr/>
         </p:nvSpPr>
@@ -13410,7 +13410,7 @@
       </p:sp>
       <p:sp>
         <p:nvSpPr>
-          <p:cNvPr id="313" name=""/>
+          <p:cNvPr id="314" name=""/>
           <p:cNvSpPr txBox="1"/>
           <p:nvPr/>
         </p:nvSpPr>
@@ -13457,7 +13457,7 @@
       </p:sp>
       <p:sp>
         <p:nvSpPr>
-          <p:cNvPr id="314" name=""/>
+          <p:cNvPr id="315" name=""/>
           <p:cNvSpPr/>
           <p:nvPr/>
         </p:nvSpPr>
@@ -13673,7 +13673,7 @@
       </p:sp>
       <p:sp>
         <p:nvSpPr>
-          <p:cNvPr id="315" name=""/>
+          <p:cNvPr id="316" name=""/>
           <p:cNvSpPr txBox="1"/>
           <p:nvPr/>
         </p:nvSpPr>
@@ -13720,7 +13720,7 @@
       </p:sp>
       <p:sp>
         <p:nvSpPr>
-          <p:cNvPr id="316" name=""/>
+          <p:cNvPr id="317" name=""/>
           <p:cNvSpPr txBox="1"/>
           <p:nvPr/>
         </p:nvSpPr>
@@ -13797,7 +13797,7 @@
       </p:grpSpPr>
       <p:sp>
         <p:nvSpPr>
-          <p:cNvPr id="317" name=""/>
+          <p:cNvPr id="318" name=""/>
           <p:cNvSpPr/>
           <p:nvPr/>
         </p:nvSpPr>
@@ -13857,7 +13857,7 @@
       </p:sp>
       <p:sp>
         <p:nvSpPr>
-          <p:cNvPr id="318" name=""/>
+          <p:cNvPr id="319" name=""/>
           <p:cNvSpPr/>
           <p:nvPr/>
         </p:nvSpPr>
@@ -13917,7 +13917,7 @@
       </p:sp>
       <p:sp>
         <p:nvSpPr>
-          <p:cNvPr id="319" name=""/>
+          <p:cNvPr id="320" name=""/>
           <p:cNvSpPr/>
           <p:nvPr/>
         </p:nvSpPr>
@@ -13977,7 +13977,7 @@
       </p:sp>
       <p:pic>
         <p:nvPicPr>
-          <p:cNvPr id="320" name="" descr=""/>
+          <p:cNvPr id="321" name="" descr=""/>
           <p:cNvPicPr/>
           <p:nvPr/>
         </p:nvPicPr>
@@ -14001,7 +14001,7 @@
       </p:pic>
       <p:sp>
         <p:nvSpPr>
-          <p:cNvPr id="321" name=""/>
+          <p:cNvPr id="322" name=""/>
           <p:cNvSpPr txBox="1"/>
           <p:nvPr/>
         </p:nvSpPr>
@@ -14048,7 +14048,7 @@
       </p:sp>
       <p:sp>
         <p:nvSpPr>
-          <p:cNvPr id="322" name=""/>
+          <p:cNvPr id="323" name=""/>
           <p:cNvSpPr txBox="1"/>
           <p:nvPr/>
         </p:nvSpPr>
@@ -14095,7 +14095,7 @@
       </p:sp>
       <p:sp>
         <p:nvSpPr>
-          <p:cNvPr id="323" name=""/>
+          <p:cNvPr id="324" name=""/>
           <p:cNvSpPr txBox="1"/>
           <p:nvPr/>
         </p:nvSpPr>
@@ -14142,7 +14142,7 @@
       </p:sp>
       <p:sp>
         <p:nvSpPr>
-          <p:cNvPr id="324" name=""/>
+          <p:cNvPr id="325" name=""/>
           <p:cNvSpPr txBox="1"/>
           <p:nvPr/>
         </p:nvSpPr>
@@ -14189,7 +14189,7 @@
       </p:sp>
       <p:sp>
         <p:nvSpPr>
-          <p:cNvPr id="325" name=""/>
+          <p:cNvPr id="326" name=""/>
           <p:cNvSpPr txBox="1"/>
           <p:nvPr/>
         </p:nvSpPr>
@@ -14236,7 +14236,7 @@
       </p:sp>
       <p:sp>
         <p:nvSpPr>
-          <p:cNvPr id="326" name=""/>
+          <p:cNvPr id="327" name=""/>
           <p:cNvSpPr txBox="1"/>
           <p:nvPr/>
         </p:nvSpPr>
@@ -14283,7 +14283,7 @@
       </p:sp>
       <p:sp>
         <p:nvSpPr>
-          <p:cNvPr id="327" name=""/>
+          <p:cNvPr id="328" name=""/>
           <p:cNvSpPr txBox="1"/>
           <p:nvPr/>
         </p:nvSpPr>
@@ -14330,7 +14330,7 @@
       </p:sp>
       <p:sp>
         <p:nvSpPr>
-          <p:cNvPr id="328" name=""/>
+          <p:cNvPr id="329" name=""/>
           <p:cNvSpPr txBox="1"/>
           <p:nvPr/>
         </p:nvSpPr>
@@ -14377,7 +14377,7 @@
       </p:sp>
       <p:sp>
         <p:nvSpPr>
-          <p:cNvPr id="329" name=""/>
+          <p:cNvPr id="330" name=""/>
           <p:cNvSpPr/>
           <p:nvPr/>
         </p:nvSpPr>
@@ -14593,7 +14593,7 @@
       </p:sp>
       <p:sp>
         <p:nvSpPr>
-          <p:cNvPr id="330" name=""/>
+          <p:cNvPr id="331" name=""/>
           <p:cNvSpPr txBox="1"/>
           <p:nvPr/>
         </p:nvSpPr>
@@ -14640,7 +14640,7 @@
       </p:sp>
       <p:sp>
         <p:nvSpPr>
-          <p:cNvPr id="331" name=""/>
+          <p:cNvPr id="332" name=""/>
           <p:cNvSpPr txBox="1"/>
           <p:nvPr/>
         </p:nvSpPr>
@@ -14717,7 +14717,7 @@
       </p:grpSpPr>
       <p:sp>
         <p:nvSpPr>
-          <p:cNvPr id="332" name=""/>
+          <p:cNvPr id="333" name=""/>
           <p:cNvSpPr/>
           <p:nvPr/>
         </p:nvSpPr>
@@ -14777,7 +14777,7 @@
       </p:sp>
       <p:sp>
         <p:nvSpPr>
-          <p:cNvPr id="333" name=""/>
+          <p:cNvPr id="334" name=""/>
           <p:cNvSpPr/>
           <p:nvPr/>
         </p:nvSpPr>
@@ -14837,7 +14837,7 @@
       </p:sp>
       <p:sp>
         <p:nvSpPr>
-          <p:cNvPr id="334" name=""/>
+          <p:cNvPr id="335" name=""/>
           <p:cNvSpPr/>
           <p:nvPr/>
         </p:nvSpPr>
@@ -14897,7 +14897,7 @@
       </p:sp>
       <p:pic>
         <p:nvPicPr>
-          <p:cNvPr id="335" name="" descr=""/>
+          <p:cNvPr id="336" name="" descr=""/>
           <p:cNvPicPr/>
           <p:nvPr/>
         </p:nvPicPr>
@@ -14921,7 +14921,7 @@
       </p:pic>
       <p:sp>
         <p:nvSpPr>
-          <p:cNvPr id="336" name=""/>
+          <p:cNvPr id="337" name=""/>
           <p:cNvSpPr txBox="1"/>
           <p:nvPr/>
         </p:nvSpPr>
@@ -14968,7 +14968,7 @@
       </p:sp>
       <p:sp>
         <p:nvSpPr>
-          <p:cNvPr id="337" name=""/>
+          <p:cNvPr id="338" name=""/>
           <p:cNvSpPr txBox="1"/>
           <p:nvPr/>
         </p:nvSpPr>
@@ -15015,7 +15015,7 @@
       </p:sp>
       <p:sp>
         <p:nvSpPr>
-          <p:cNvPr id="338" name=""/>
+          <p:cNvPr id="339" name=""/>
           <p:cNvSpPr txBox="1"/>
           <p:nvPr/>
         </p:nvSpPr>
@@ -15074,7 +15074,7 @@
       </p:sp>
       <p:sp>
         <p:nvSpPr>
-          <p:cNvPr id="339" name=""/>
+          <p:cNvPr id="340" name=""/>
           <p:cNvSpPr txBox="1"/>
           <p:nvPr/>
         </p:nvSpPr>
@@ -15121,7 +15121,7 @@
       </p:sp>
       <p:sp>
         <p:nvSpPr>
-          <p:cNvPr id="340" name=""/>
+          <p:cNvPr id="341" name=""/>
           <p:cNvSpPr txBox="1"/>
           <p:nvPr/>
         </p:nvSpPr>
@@ -15168,7 +15168,7 @@
       </p:sp>
       <p:sp>
         <p:nvSpPr>
-          <p:cNvPr id="341" name=""/>
+          <p:cNvPr id="342" name=""/>
           <p:cNvSpPr txBox="1"/>
           <p:nvPr/>
         </p:nvSpPr>
@@ -15215,7 +15215,7 @@
       </p:sp>
       <p:sp>
         <p:nvSpPr>
-          <p:cNvPr id="342" name=""/>
+          <p:cNvPr id="343" name=""/>
           <p:cNvSpPr txBox="1"/>
           <p:nvPr/>
         </p:nvSpPr>
@@ -15262,7 +15262,7 @@
       </p:sp>
       <p:sp>
         <p:nvSpPr>
-          <p:cNvPr id="343" name=""/>
+          <p:cNvPr id="344" name=""/>
           <p:cNvSpPr txBox="1"/>
           <p:nvPr/>
         </p:nvSpPr>
@@ -15309,7 +15309,7 @@
       </p:sp>
       <p:sp>
         <p:nvSpPr>
-          <p:cNvPr id="344" name=""/>
+          <p:cNvPr id="345" name=""/>
           <p:cNvSpPr txBox="1"/>
           <p:nvPr/>
         </p:nvSpPr>
@@ -15356,7 +15356,7 @@
       </p:sp>
       <p:sp>
         <p:nvSpPr>
-          <p:cNvPr id="345" name=""/>
+          <p:cNvPr id="346" name=""/>
           <p:cNvSpPr txBox="1"/>
           <p:nvPr/>
         </p:nvSpPr>
@@ -15403,7 +15403,7 @@
       </p:sp>
       <p:sp>
         <p:nvSpPr>
-          <p:cNvPr id="346" name=""/>
+          <p:cNvPr id="347" name=""/>
           <p:cNvSpPr txBox="1"/>
           <p:nvPr/>
         </p:nvSpPr>
@@ -24733,12 +24733,526 @@
       <p:sp>
         <p:nvSpPr>
           <p:cNvPr id="137" name=""/>
+          <p:cNvSpPr/>
+          <p:nvPr/>
+        </p:nvSpPr>
+        <p:spPr>
+          <a:xfrm>
+            <a:off x="847440" y="2327400"/>
+            <a:ext cx="810000" cy="765000"/>
+          </a:xfrm>
+          <a:custGeom>
+            <a:avLst/>
+            <a:gdLst/>
+            <a:ahLst/>
+            <a:rect l="0" t="0" r="r" b="b"/>
+            <a:pathLst>
+              <a:path w="2250" h="2125">
+                <a:moveTo>
+                  <a:pt x="1126" y="0"/>
+                </a:moveTo>
+                <a:cubicBezTo>
+                  <a:pt x="504" y="0"/>
+                  <a:pt x="0" y="391"/>
+                  <a:pt x="0" y="874"/>
+                </a:cubicBezTo>
+                <a:cubicBezTo>
+                  <a:pt x="0" y="1148"/>
+                  <a:pt x="161" y="1392"/>
+                  <a:pt x="413" y="1552"/>
+                </a:cubicBezTo>
+                <a:cubicBezTo>
+                  <a:pt x="380" y="1697"/>
+                  <a:pt x="304" y="1911"/>
+                  <a:pt x="125" y="2125"/>
+                </a:cubicBezTo>
+                <a:cubicBezTo>
+                  <a:pt x="485" y="2065"/>
+                  <a:pt x="715" y="1890"/>
+                  <a:pt x="857" y="1724"/>
+                </a:cubicBezTo>
+                <a:cubicBezTo>
+                  <a:pt x="943" y="1740"/>
+                  <a:pt x="1033" y="1750"/>
+                  <a:pt x="1126" y="1750"/>
+                </a:cubicBezTo>
+                <a:cubicBezTo>
+                  <a:pt x="1747" y="1750"/>
+                  <a:pt x="2250" y="1359"/>
+                  <a:pt x="2250" y="874"/>
+                </a:cubicBezTo>
+                <a:cubicBezTo>
+                  <a:pt x="2250" y="391"/>
+                  <a:pt x="1747" y="0"/>
+                  <a:pt x="1126" y="0"/>
+                </a:cubicBezTo>
+                <a:close/>
+              </a:path>
+            </a:pathLst>
+          </a:custGeom>
+          <a:solidFill>
+            <a:srgbClr val="bdddf4"/>
+          </a:solidFill>
+          <a:ln w="0">
+            <a:noFill/>
+          </a:ln>
+        </p:spPr>
+        <p:txBody>
+          <a:bodyPr lIns="0" rIns="0" tIns="0" bIns="0" anchor="t">
+            <a:noAutofit/>
+          </a:bodyPr>
+          <a:p>
+            <a:endParaRPr b="0" lang="en-US" sz="2400" strike="noStrike" u="none">
+              <a:solidFill>
+                <a:srgbClr val="000000"/>
+              </a:solidFill>
+              <a:effectLst/>
+              <a:uFillTx/>
+              <a:latin typeface="Times New Roman"/>
+            </a:endParaRPr>
+          </a:p>
+        </p:txBody>
+      </p:sp>
+      <p:sp>
+        <p:nvSpPr>
+          <p:cNvPr id="138" name=""/>
+          <p:cNvSpPr/>
+          <p:nvPr/>
+        </p:nvSpPr>
+        <p:spPr>
+          <a:xfrm>
+            <a:off x="1207440" y="2597400"/>
+            <a:ext cx="90360" cy="90000"/>
+          </a:xfrm>
+          <a:custGeom>
+            <a:avLst/>
+            <a:gdLst/>
+            <a:ahLst/>
+            <a:rect l="0" t="0" r="r" b="b"/>
+            <a:pathLst>
+              <a:path w="251" h="250">
+                <a:moveTo>
+                  <a:pt x="251" y="124"/>
+                </a:moveTo>
+                <a:cubicBezTo>
+                  <a:pt x="251" y="142"/>
+                  <a:pt x="248" y="158"/>
+                  <a:pt x="241" y="173"/>
+                </a:cubicBezTo>
+                <a:cubicBezTo>
+                  <a:pt x="235" y="189"/>
+                  <a:pt x="226" y="202"/>
+                  <a:pt x="214" y="214"/>
+                </a:cubicBezTo>
+                <a:cubicBezTo>
+                  <a:pt x="202" y="226"/>
+                  <a:pt x="189" y="235"/>
+                  <a:pt x="174" y="241"/>
+                </a:cubicBezTo>
+                <a:cubicBezTo>
+                  <a:pt x="158" y="247"/>
+                  <a:pt x="142" y="250"/>
+                  <a:pt x="126" y="250"/>
+                </a:cubicBezTo>
+                <a:cubicBezTo>
+                  <a:pt x="109" y="250"/>
+                  <a:pt x="93" y="247"/>
+                  <a:pt x="78" y="241"/>
+                </a:cubicBezTo>
+                <a:cubicBezTo>
+                  <a:pt x="63" y="235"/>
+                  <a:pt x="49" y="226"/>
+                  <a:pt x="37" y="214"/>
+                </a:cubicBezTo>
+                <a:cubicBezTo>
+                  <a:pt x="26" y="202"/>
+                  <a:pt x="17" y="189"/>
+                  <a:pt x="10" y="173"/>
+                </a:cubicBezTo>
+                <a:cubicBezTo>
+                  <a:pt x="3" y="158"/>
+                  <a:pt x="0" y="142"/>
+                  <a:pt x="0" y="124"/>
+                </a:cubicBezTo>
+                <a:cubicBezTo>
+                  <a:pt x="0" y="108"/>
+                  <a:pt x="3" y="92"/>
+                  <a:pt x="10" y="77"/>
+                </a:cubicBezTo>
+                <a:cubicBezTo>
+                  <a:pt x="17" y="61"/>
+                  <a:pt x="26" y="48"/>
+                  <a:pt x="37" y="36"/>
+                </a:cubicBezTo>
+                <a:cubicBezTo>
+                  <a:pt x="49" y="24"/>
+                  <a:pt x="63" y="15"/>
+                  <a:pt x="78" y="9"/>
+                </a:cubicBezTo>
+                <a:cubicBezTo>
+                  <a:pt x="93" y="3"/>
+                  <a:pt x="109" y="0"/>
+                  <a:pt x="126" y="0"/>
+                </a:cubicBezTo>
+                <a:cubicBezTo>
+                  <a:pt x="142" y="0"/>
+                  <a:pt x="158" y="3"/>
+                  <a:pt x="174" y="9"/>
+                </a:cubicBezTo>
+                <a:cubicBezTo>
+                  <a:pt x="189" y="15"/>
+                  <a:pt x="202" y="24"/>
+                  <a:pt x="214" y="36"/>
+                </a:cubicBezTo>
+                <a:cubicBezTo>
+                  <a:pt x="226" y="48"/>
+                  <a:pt x="235" y="61"/>
+                  <a:pt x="241" y="77"/>
+                </a:cubicBezTo>
+                <a:cubicBezTo>
+                  <a:pt x="248" y="92"/>
+                  <a:pt x="251" y="108"/>
+                  <a:pt x="251" y="124"/>
+                </a:cubicBezTo>
+                <a:close/>
+              </a:path>
+            </a:pathLst>
+          </a:custGeom>
+          <a:solidFill>
+            <a:srgbClr val="2a6797"/>
+          </a:solidFill>
+          <a:ln w="0">
+            <a:noFill/>
+          </a:ln>
+        </p:spPr>
+        <p:txBody>
+          <a:bodyPr lIns="0" rIns="0" tIns="0" bIns="0" anchor="t">
+            <a:noAutofit/>
+          </a:bodyPr>
+          <a:p>
+            <a:endParaRPr b="0" lang="en-US" sz="2400" strike="noStrike" u="none">
+              <a:solidFill>
+                <a:srgbClr val="ffffff"/>
+              </a:solidFill>
+              <a:effectLst/>
+              <a:uFillTx/>
+              <a:latin typeface="Times New Roman"/>
+            </a:endParaRPr>
+          </a:p>
+        </p:txBody>
+      </p:sp>
+      <p:sp>
+        <p:nvSpPr>
+          <p:cNvPr id="139" name=""/>
+          <p:cNvSpPr/>
+          <p:nvPr/>
+        </p:nvSpPr>
+        <p:spPr>
+          <a:xfrm>
+            <a:off x="1387440" y="2597400"/>
+            <a:ext cx="90000" cy="90000"/>
+          </a:xfrm>
+          <a:custGeom>
+            <a:avLst/>
+            <a:gdLst/>
+            <a:ahLst/>
+            <a:rect l="0" t="0" r="r" b="b"/>
+            <a:pathLst>
+              <a:path w="250" h="250">
+                <a:moveTo>
+                  <a:pt x="250" y="124"/>
+                </a:moveTo>
+                <a:cubicBezTo>
+                  <a:pt x="250" y="142"/>
+                  <a:pt x="247" y="158"/>
+                  <a:pt x="241" y="173"/>
+                </a:cubicBezTo>
+                <a:cubicBezTo>
+                  <a:pt x="235" y="189"/>
+                  <a:pt x="226" y="202"/>
+                  <a:pt x="214" y="214"/>
+                </a:cubicBezTo>
+                <a:cubicBezTo>
+                  <a:pt x="202" y="226"/>
+                  <a:pt x="189" y="235"/>
+                  <a:pt x="173" y="241"/>
+                </a:cubicBezTo>
+                <a:cubicBezTo>
+                  <a:pt x="158" y="247"/>
+                  <a:pt x="142" y="250"/>
+                  <a:pt x="126" y="250"/>
+                </a:cubicBezTo>
+                <a:cubicBezTo>
+                  <a:pt x="109" y="250"/>
+                  <a:pt x="93" y="247"/>
+                  <a:pt x="78" y="241"/>
+                </a:cubicBezTo>
+                <a:cubicBezTo>
+                  <a:pt x="62" y="235"/>
+                  <a:pt x="49" y="226"/>
+                  <a:pt x="37" y="214"/>
+                </a:cubicBezTo>
+                <a:cubicBezTo>
+                  <a:pt x="25" y="202"/>
+                  <a:pt x="16" y="189"/>
+                  <a:pt x="10" y="173"/>
+                </a:cubicBezTo>
+                <a:cubicBezTo>
+                  <a:pt x="3" y="158"/>
+                  <a:pt x="0" y="142"/>
+                  <a:pt x="0" y="124"/>
+                </a:cubicBezTo>
+                <a:cubicBezTo>
+                  <a:pt x="0" y="108"/>
+                  <a:pt x="3" y="92"/>
+                  <a:pt x="10" y="77"/>
+                </a:cubicBezTo>
+                <a:cubicBezTo>
+                  <a:pt x="16" y="61"/>
+                  <a:pt x="25" y="48"/>
+                  <a:pt x="37" y="36"/>
+                </a:cubicBezTo>
+                <a:cubicBezTo>
+                  <a:pt x="49" y="24"/>
+                  <a:pt x="62" y="15"/>
+                  <a:pt x="78" y="9"/>
+                </a:cubicBezTo>
+                <a:cubicBezTo>
+                  <a:pt x="93" y="3"/>
+                  <a:pt x="109" y="0"/>
+                  <a:pt x="126" y="0"/>
+                </a:cubicBezTo>
+                <a:cubicBezTo>
+                  <a:pt x="142" y="0"/>
+                  <a:pt x="158" y="3"/>
+                  <a:pt x="173" y="9"/>
+                </a:cubicBezTo>
+                <a:cubicBezTo>
+                  <a:pt x="189" y="15"/>
+                  <a:pt x="202" y="24"/>
+                  <a:pt x="214" y="36"/>
+                </a:cubicBezTo>
+                <a:cubicBezTo>
+                  <a:pt x="226" y="48"/>
+                  <a:pt x="235" y="61"/>
+                  <a:pt x="241" y="77"/>
+                </a:cubicBezTo>
+                <a:cubicBezTo>
+                  <a:pt x="247" y="92"/>
+                  <a:pt x="250" y="108"/>
+                  <a:pt x="250" y="124"/>
+                </a:cubicBezTo>
+                <a:close/>
+              </a:path>
+            </a:pathLst>
+          </a:custGeom>
+          <a:solidFill>
+            <a:srgbClr val="2a6797"/>
+          </a:solidFill>
+          <a:ln w="0">
+            <a:noFill/>
+          </a:ln>
+        </p:spPr>
+        <p:txBody>
+          <a:bodyPr lIns="0" rIns="0" tIns="0" bIns="0" anchor="t">
+            <a:noAutofit/>
+          </a:bodyPr>
+          <a:p>
+            <a:endParaRPr b="0" lang="en-US" sz="2400" strike="noStrike" u="none">
+              <a:solidFill>
+                <a:srgbClr val="ffffff"/>
+              </a:solidFill>
+              <a:effectLst/>
+              <a:uFillTx/>
+              <a:latin typeface="Times New Roman"/>
+            </a:endParaRPr>
+          </a:p>
+        </p:txBody>
+      </p:sp>
+      <p:sp>
+        <p:nvSpPr>
+          <p:cNvPr id="140" name=""/>
+          <p:cNvSpPr/>
+          <p:nvPr/>
+        </p:nvSpPr>
+        <p:spPr>
+          <a:xfrm>
+            <a:off x="1027440" y="2597400"/>
+            <a:ext cx="90360" cy="90000"/>
+          </a:xfrm>
+          <a:custGeom>
+            <a:avLst/>
+            <a:gdLst/>
+            <a:ahLst/>
+            <a:rect l="0" t="0" r="r" b="b"/>
+            <a:pathLst>
+              <a:path w="251" h="250">
+                <a:moveTo>
+                  <a:pt x="251" y="124"/>
+                </a:moveTo>
+                <a:cubicBezTo>
+                  <a:pt x="251" y="142"/>
+                  <a:pt x="248" y="158"/>
+                  <a:pt x="241" y="173"/>
+                </a:cubicBezTo>
+                <a:cubicBezTo>
+                  <a:pt x="235" y="189"/>
+                  <a:pt x="226" y="202"/>
+                  <a:pt x="214" y="214"/>
+                </a:cubicBezTo>
+                <a:cubicBezTo>
+                  <a:pt x="203" y="226"/>
+                  <a:pt x="189" y="235"/>
+                  <a:pt x="174" y="241"/>
+                </a:cubicBezTo>
+                <a:cubicBezTo>
+                  <a:pt x="159" y="247"/>
+                  <a:pt x="143" y="250"/>
+                  <a:pt x="126" y="250"/>
+                </a:cubicBezTo>
+                <a:cubicBezTo>
+                  <a:pt x="109" y="250"/>
+                  <a:pt x="93" y="247"/>
+                  <a:pt x="78" y="241"/>
+                </a:cubicBezTo>
+                <a:cubicBezTo>
+                  <a:pt x="63" y="235"/>
+                  <a:pt x="49" y="226"/>
+                  <a:pt x="38" y="214"/>
+                </a:cubicBezTo>
+                <a:cubicBezTo>
+                  <a:pt x="26" y="202"/>
+                  <a:pt x="17" y="189"/>
+                  <a:pt x="11" y="173"/>
+                </a:cubicBezTo>
+                <a:cubicBezTo>
+                  <a:pt x="3" y="158"/>
+                  <a:pt x="0" y="142"/>
+                  <a:pt x="0" y="124"/>
+                </a:cubicBezTo>
+                <a:cubicBezTo>
+                  <a:pt x="0" y="108"/>
+                  <a:pt x="3" y="92"/>
+                  <a:pt x="11" y="77"/>
+                </a:cubicBezTo>
+                <a:cubicBezTo>
+                  <a:pt x="17" y="61"/>
+                  <a:pt x="26" y="48"/>
+                  <a:pt x="38" y="36"/>
+                </a:cubicBezTo>
+                <a:cubicBezTo>
+                  <a:pt x="49" y="24"/>
+                  <a:pt x="63" y="15"/>
+                  <a:pt x="78" y="9"/>
+                </a:cubicBezTo>
+                <a:cubicBezTo>
+                  <a:pt x="93" y="3"/>
+                  <a:pt x="109" y="0"/>
+                  <a:pt x="126" y="0"/>
+                </a:cubicBezTo>
+                <a:cubicBezTo>
+                  <a:pt x="143" y="0"/>
+                  <a:pt x="159" y="3"/>
+                  <a:pt x="174" y="9"/>
+                </a:cubicBezTo>
+                <a:cubicBezTo>
+                  <a:pt x="189" y="15"/>
+                  <a:pt x="203" y="24"/>
+                  <a:pt x="214" y="36"/>
+                </a:cubicBezTo>
+                <a:cubicBezTo>
+                  <a:pt x="226" y="48"/>
+                  <a:pt x="235" y="61"/>
+                  <a:pt x="241" y="77"/>
+                </a:cubicBezTo>
+                <a:cubicBezTo>
+                  <a:pt x="248" y="92"/>
+                  <a:pt x="251" y="108"/>
+                  <a:pt x="251" y="124"/>
+                </a:cubicBezTo>
+                <a:close/>
+              </a:path>
+            </a:pathLst>
+          </a:custGeom>
+          <a:solidFill>
+            <a:srgbClr val="2a6797"/>
+          </a:solidFill>
+          <a:ln w="0">
+            <a:noFill/>
+          </a:ln>
+        </p:spPr>
+        <p:txBody>
+          <a:bodyPr lIns="0" rIns="0" tIns="0" bIns="0" anchor="t">
+            <a:noAutofit/>
+          </a:bodyPr>
+          <a:p>
+            <a:endParaRPr b="0" lang="en-US" sz="2400" strike="noStrike" u="none">
+              <a:solidFill>
+                <a:srgbClr val="ffffff"/>
+              </a:solidFill>
+              <a:effectLst/>
+              <a:uFillTx/>
+              <a:latin typeface="Times New Roman"/>
+            </a:endParaRPr>
+          </a:p>
+        </p:txBody>
+      </p:sp>
+      <p:sp>
+        <p:nvSpPr>
+          <p:cNvPr id="141" name=""/>
           <p:cNvSpPr txBox="1"/>
           <p:nvPr/>
         </p:nvSpPr>
         <p:spPr>
           <a:xfrm>
-            <a:off x="762120" y="3451680"/>
+            <a:off x="1696680" y="2252520"/>
+            <a:ext cx="6165720" cy="955800"/>
+          </a:xfrm>
+          <a:prstGeom prst="rect">
+            <a:avLst/>
+          </a:prstGeom>
+          <a:noFill/>
+          <a:ln w="0">
+            <a:noFill/>
+          </a:ln>
+        </p:spPr>
+        <p:txBody>
+          <a:bodyPr wrap="none" lIns="0" rIns="0" tIns="0" bIns="0" anchor="t">
+            <a:spAutoFit/>
+          </a:bodyPr>
+          <a:p>
+            <a:r>
+              <a:rPr b="1" lang="en-US" sz="6400" strike="noStrike" u="none">
+                <a:solidFill>
+                  <a:srgbClr val="ffffff"/>
+                </a:solidFill>
+                <a:effectLst/>
+                <a:uFillTx/>
+                <a:latin typeface="LucidaGrande"/>
+                <a:ea typeface="LucidaGrande"/>
+              </a:rPr>
+              <a:t> Turn and Talk</a:t>
+            </a:r>
+            <a:endParaRPr b="0" lang="en-US" sz="6400" strike="noStrike" u="none">
+              <a:solidFill>
+                <a:srgbClr val="000000"/>
+              </a:solidFill>
+              <a:effectLst/>
+              <a:uFillTx/>
+              <a:latin typeface="Times New Roman"/>
+            </a:endParaRPr>
+          </a:p>
+        </p:txBody>
+      </p:sp>
+      <p:sp>
+        <p:nvSpPr>
+          <p:cNvPr id="142" name=""/>
+          <p:cNvSpPr txBox="1"/>
+          <p:nvPr/>
+        </p:nvSpPr>
+        <p:spPr>
+          <a:xfrm>
+            <a:off x="762120" y="3927960"/>
             <a:ext cx="8168760" cy="239760"/>
           </a:xfrm>
           <a:prstGeom prst="rect">
@@ -24779,481 +25293,61 @@
       </p:sp>
       <p:sp>
         <p:nvSpPr>
-          <p:cNvPr id="138" name=""/>
-          <p:cNvSpPr/>
-          <p:nvPr/>
-        </p:nvSpPr>
-        <p:spPr>
-          <a:xfrm>
-            <a:off x="799920" y="3716280"/>
-            <a:ext cx="410040" cy="378000"/>
-          </a:xfrm>
-          <a:custGeom>
-            <a:avLst/>
-            <a:gdLst/>
-            <a:ahLst/>
-            <a:rect l="0" t="0" r="r" b="b"/>
-            <a:pathLst>
-              <a:path w="1139" h="1050">
-                <a:moveTo>
-                  <a:pt x="569" y="0"/>
-                </a:moveTo>
-                <a:cubicBezTo>
-                  <a:pt x="255" y="0"/>
-                  <a:pt x="0" y="193"/>
-                  <a:pt x="0" y="432"/>
-                </a:cubicBezTo>
-                <a:cubicBezTo>
-                  <a:pt x="0" y="567"/>
-                  <a:pt x="81" y="687"/>
-                  <a:pt x="209" y="767"/>
-                </a:cubicBezTo>
-                <a:cubicBezTo>
-                  <a:pt x="192" y="839"/>
-                  <a:pt x="154" y="944"/>
-                  <a:pt x="63" y="1050"/>
-                </a:cubicBezTo>
-                <a:cubicBezTo>
-                  <a:pt x="245" y="1021"/>
-                  <a:pt x="362" y="934"/>
-                  <a:pt x="433" y="852"/>
-                </a:cubicBezTo>
-                <a:cubicBezTo>
-                  <a:pt x="477" y="860"/>
-                  <a:pt x="522" y="865"/>
-                  <a:pt x="569" y="865"/>
-                </a:cubicBezTo>
-                <a:cubicBezTo>
-                  <a:pt x="884" y="865"/>
-                  <a:pt x="1139" y="670"/>
-                  <a:pt x="1139" y="432"/>
-                </a:cubicBezTo>
-                <a:cubicBezTo>
-                  <a:pt x="1139" y="193"/>
-                  <a:pt x="884" y="0"/>
-                  <a:pt x="569" y="0"/>
-                </a:cubicBezTo>
-                <a:close/>
-              </a:path>
-            </a:pathLst>
-          </a:custGeom>
-          <a:solidFill>
-            <a:srgbClr val="bdddf4"/>
-          </a:solidFill>
-          <a:ln w="0">
-            <a:noFill/>
-          </a:ln>
-        </p:spPr>
-        <p:txBody>
-          <a:bodyPr lIns="0" rIns="0" tIns="0" bIns="0" anchor="t">
-            <a:noAutofit/>
-          </a:bodyPr>
-          <a:p>
-            <a:endParaRPr b="0" lang="en-US" sz="2400" strike="noStrike" u="none">
-              <a:solidFill>
-                <a:srgbClr val="000000"/>
-              </a:solidFill>
-              <a:effectLst/>
-              <a:uFillTx/>
-              <a:latin typeface="Times New Roman"/>
-            </a:endParaRPr>
-          </a:p>
-        </p:txBody>
-      </p:sp>
-      <p:sp>
-        <p:nvSpPr>
-          <p:cNvPr id="139" name=""/>
-          <p:cNvSpPr/>
-          <p:nvPr/>
-        </p:nvSpPr>
-        <p:spPr>
-          <a:xfrm>
-            <a:off x="982080" y="3849480"/>
-            <a:ext cx="45720" cy="45000"/>
-          </a:xfrm>
-          <a:custGeom>
-            <a:avLst/>
-            <a:gdLst/>
-            <a:ahLst/>
-            <a:rect l="0" t="0" r="r" b="b"/>
-            <a:pathLst>
-              <a:path w="127" h="125">
-                <a:moveTo>
-                  <a:pt x="127" y="62"/>
-                </a:moveTo>
-                <a:cubicBezTo>
-                  <a:pt x="127" y="71"/>
-                  <a:pt x="125" y="79"/>
-                  <a:pt x="122" y="86"/>
-                </a:cubicBezTo>
-                <a:cubicBezTo>
-                  <a:pt x="119" y="94"/>
-                  <a:pt x="114" y="101"/>
-                  <a:pt x="109" y="106"/>
-                </a:cubicBezTo>
-                <a:cubicBezTo>
-                  <a:pt x="102" y="112"/>
-                  <a:pt x="95" y="117"/>
-                  <a:pt x="87" y="120"/>
-                </a:cubicBezTo>
-                <a:cubicBezTo>
-                  <a:pt x="79" y="123"/>
-                  <a:pt x="71" y="125"/>
-                  <a:pt x="63" y="125"/>
-                </a:cubicBezTo>
-                <a:cubicBezTo>
-                  <a:pt x="54" y="125"/>
-                  <a:pt x="46" y="123"/>
-                  <a:pt x="39" y="120"/>
-                </a:cubicBezTo>
-                <a:cubicBezTo>
-                  <a:pt x="31" y="117"/>
-                  <a:pt x="24" y="112"/>
-                  <a:pt x="18" y="106"/>
-                </a:cubicBezTo>
-                <a:cubicBezTo>
-                  <a:pt x="12" y="101"/>
-                  <a:pt x="8" y="94"/>
-                  <a:pt x="4" y="86"/>
-                </a:cubicBezTo>
-                <a:cubicBezTo>
-                  <a:pt x="1" y="79"/>
-                  <a:pt x="0" y="71"/>
-                  <a:pt x="0" y="62"/>
-                </a:cubicBezTo>
-                <a:cubicBezTo>
-                  <a:pt x="0" y="54"/>
-                  <a:pt x="1" y="46"/>
-                  <a:pt x="4" y="38"/>
-                </a:cubicBezTo>
-                <a:cubicBezTo>
-                  <a:pt x="8" y="31"/>
-                  <a:pt x="12" y="24"/>
-                  <a:pt x="18" y="18"/>
-                </a:cubicBezTo>
-                <a:cubicBezTo>
-                  <a:pt x="24" y="12"/>
-                  <a:pt x="31" y="8"/>
-                  <a:pt x="39" y="5"/>
-                </a:cubicBezTo>
-                <a:cubicBezTo>
-                  <a:pt x="46" y="2"/>
-                  <a:pt x="54" y="0"/>
-                  <a:pt x="63" y="0"/>
-                </a:cubicBezTo>
-                <a:cubicBezTo>
-                  <a:pt x="71" y="0"/>
-                  <a:pt x="79" y="2"/>
-                  <a:pt x="87" y="5"/>
-                </a:cubicBezTo>
-                <a:cubicBezTo>
-                  <a:pt x="95" y="8"/>
-                  <a:pt x="102" y="12"/>
-                  <a:pt x="109" y="18"/>
-                </a:cubicBezTo>
-                <a:cubicBezTo>
-                  <a:pt x="114" y="24"/>
-                  <a:pt x="119" y="31"/>
-                  <a:pt x="122" y="38"/>
-                </a:cubicBezTo>
-                <a:cubicBezTo>
-                  <a:pt x="125" y="46"/>
-                  <a:pt x="127" y="54"/>
-                  <a:pt x="127" y="62"/>
-                </a:cubicBezTo>
-                <a:close/>
-              </a:path>
-            </a:pathLst>
-          </a:custGeom>
-          <a:solidFill>
-            <a:srgbClr val="2a6797"/>
-          </a:solidFill>
-          <a:ln w="0">
-            <a:noFill/>
-          </a:ln>
-        </p:spPr>
-        <p:txBody>
-          <a:bodyPr lIns="0" rIns="0" tIns="0" bIns="0" anchor="t">
-            <a:noAutofit/>
-          </a:bodyPr>
-          <a:p>
-            <a:endParaRPr b="0" lang="en-US" sz="2400" strike="noStrike" u="none">
-              <a:solidFill>
-                <a:srgbClr val="ffffff"/>
-              </a:solidFill>
-              <a:effectLst/>
-              <a:uFillTx/>
-              <a:latin typeface="Times New Roman"/>
-            </a:endParaRPr>
-          </a:p>
-        </p:txBody>
-      </p:sp>
-      <p:sp>
-        <p:nvSpPr>
-          <p:cNvPr id="140" name=""/>
-          <p:cNvSpPr/>
-          <p:nvPr/>
-        </p:nvSpPr>
-        <p:spPr>
-          <a:xfrm>
-            <a:off x="1072800" y="3849480"/>
-            <a:ext cx="46080" cy="45000"/>
-          </a:xfrm>
-          <a:custGeom>
-            <a:avLst/>
-            <a:gdLst/>
-            <a:ahLst/>
-            <a:rect l="0" t="0" r="r" b="b"/>
-            <a:pathLst>
-              <a:path w="128" h="125">
-                <a:moveTo>
-                  <a:pt x="128" y="62"/>
-                </a:moveTo>
-                <a:cubicBezTo>
-                  <a:pt x="128" y="71"/>
-                  <a:pt x="126" y="79"/>
-                  <a:pt x="123" y="86"/>
-                </a:cubicBezTo>
-                <a:cubicBezTo>
-                  <a:pt x="120" y="94"/>
-                  <a:pt x="115" y="101"/>
-                  <a:pt x="109" y="106"/>
-                </a:cubicBezTo>
-                <a:cubicBezTo>
-                  <a:pt x="102" y="112"/>
-                  <a:pt x="96" y="117"/>
-                  <a:pt x="88" y="120"/>
-                </a:cubicBezTo>
-                <a:cubicBezTo>
-                  <a:pt x="80" y="123"/>
-                  <a:pt x="72" y="125"/>
-                  <a:pt x="64" y="125"/>
-                </a:cubicBezTo>
-                <a:cubicBezTo>
-                  <a:pt x="55" y="125"/>
-                  <a:pt x="47" y="123"/>
-                  <a:pt x="39" y="120"/>
-                </a:cubicBezTo>
-                <a:cubicBezTo>
-                  <a:pt x="32" y="117"/>
-                  <a:pt x="25" y="112"/>
-                  <a:pt x="19" y="106"/>
-                </a:cubicBezTo>
-                <a:cubicBezTo>
-                  <a:pt x="13" y="101"/>
-                  <a:pt x="8" y="94"/>
-                  <a:pt x="5" y="86"/>
-                </a:cubicBezTo>
-                <a:cubicBezTo>
-                  <a:pt x="2" y="79"/>
-                  <a:pt x="0" y="71"/>
-                  <a:pt x="0" y="62"/>
-                </a:cubicBezTo>
-                <a:cubicBezTo>
-                  <a:pt x="0" y="54"/>
-                  <a:pt x="2" y="46"/>
-                  <a:pt x="5" y="38"/>
-                </a:cubicBezTo>
-                <a:cubicBezTo>
-                  <a:pt x="8" y="31"/>
-                  <a:pt x="13" y="24"/>
-                  <a:pt x="19" y="18"/>
-                </a:cubicBezTo>
-                <a:cubicBezTo>
-                  <a:pt x="25" y="12"/>
-                  <a:pt x="32" y="8"/>
-                  <a:pt x="39" y="5"/>
-                </a:cubicBezTo>
-                <a:cubicBezTo>
-                  <a:pt x="47" y="2"/>
-                  <a:pt x="55" y="0"/>
-                  <a:pt x="64" y="0"/>
-                </a:cubicBezTo>
-                <a:cubicBezTo>
-                  <a:pt x="72" y="0"/>
-                  <a:pt x="80" y="2"/>
-                  <a:pt x="88" y="5"/>
-                </a:cubicBezTo>
-                <a:cubicBezTo>
-                  <a:pt x="96" y="8"/>
-                  <a:pt x="102" y="12"/>
-                  <a:pt x="109" y="18"/>
-                </a:cubicBezTo>
-                <a:cubicBezTo>
-                  <a:pt x="115" y="24"/>
-                  <a:pt x="120" y="31"/>
-                  <a:pt x="123" y="38"/>
-                </a:cubicBezTo>
-                <a:cubicBezTo>
-                  <a:pt x="126" y="46"/>
-                  <a:pt x="128" y="54"/>
-                  <a:pt x="128" y="62"/>
-                </a:cubicBezTo>
-                <a:close/>
-              </a:path>
-            </a:pathLst>
-          </a:custGeom>
-          <a:solidFill>
-            <a:srgbClr val="2a6797"/>
-          </a:solidFill>
-          <a:ln w="0">
-            <a:noFill/>
-          </a:ln>
-        </p:spPr>
-        <p:txBody>
-          <a:bodyPr lIns="0" rIns="0" tIns="0" bIns="0" anchor="t">
-            <a:noAutofit/>
-          </a:bodyPr>
-          <a:p>
-            <a:endParaRPr b="0" lang="en-US" sz="2400" strike="noStrike" u="none">
-              <a:solidFill>
-                <a:srgbClr val="ffffff"/>
-              </a:solidFill>
-              <a:effectLst/>
-              <a:uFillTx/>
-              <a:latin typeface="Times New Roman"/>
-            </a:endParaRPr>
-          </a:p>
-        </p:txBody>
-      </p:sp>
-      <p:sp>
-        <p:nvSpPr>
-          <p:cNvPr id="141" name=""/>
-          <p:cNvSpPr/>
-          <p:nvPr/>
-        </p:nvSpPr>
-        <p:spPr>
-          <a:xfrm>
-            <a:off x="891000" y="3849480"/>
-            <a:ext cx="45720" cy="45000"/>
-          </a:xfrm>
-          <a:custGeom>
-            <a:avLst/>
-            <a:gdLst/>
-            <a:ahLst/>
-            <a:rect l="0" t="0" r="r" b="b"/>
-            <a:pathLst>
-              <a:path w="127" h="125">
-                <a:moveTo>
-                  <a:pt x="127" y="62"/>
-                </a:moveTo>
-                <a:cubicBezTo>
-                  <a:pt x="127" y="71"/>
-                  <a:pt x="126" y="79"/>
-                  <a:pt x="122" y="86"/>
-                </a:cubicBezTo>
-                <a:cubicBezTo>
-                  <a:pt x="119" y="94"/>
-                  <a:pt x="115" y="101"/>
-                  <a:pt x="109" y="106"/>
-                </a:cubicBezTo>
-                <a:cubicBezTo>
-                  <a:pt x="102" y="112"/>
-                  <a:pt x="95" y="117"/>
-                  <a:pt x="87" y="120"/>
-                </a:cubicBezTo>
-                <a:cubicBezTo>
-                  <a:pt x="79" y="123"/>
-                  <a:pt x="71" y="125"/>
-                  <a:pt x="63" y="125"/>
-                </a:cubicBezTo>
-                <a:cubicBezTo>
-                  <a:pt x="55" y="125"/>
-                  <a:pt x="47" y="123"/>
-                  <a:pt x="39" y="120"/>
-                </a:cubicBezTo>
-                <a:cubicBezTo>
-                  <a:pt x="31" y="117"/>
-                  <a:pt x="24" y="112"/>
-                  <a:pt x="18" y="106"/>
-                </a:cubicBezTo>
-                <a:cubicBezTo>
-                  <a:pt x="12" y="101"/>
-                  <a:pt x="8" y="94"/>
-                  <a:pt x="5" y="86"/>
-                </a:cubicBezTo>
-                <a:cubicBezTo>
-                  <a:pt x="1" y="79"/>
-                  <a:pt x="0" y="71"/>
-                  <a:pt x="0" y="62"/>
-                </a:cubicBezTo>
-                <a:cubicBezTo>
-                  <a:pt x="0" y="54"/>
-                  <a:pt x="1" y="46"/>
-                  <a:pt x="5" y="38"/>
-                </a:cubicBezTo>
-                <a:cubicBezTo>
-                  <a:pt x="8" y="31"/>
-                  <a:pt x="12" y="24"/>
-                  <a:pt x="18" y="18"/>
-                </a:cubicBezTo>
-                <a:cubicBezTo>
-                  <a:pt x="24" y="12"/>
-                  <a:pt x="31" y="8"/>
-                  <a:pt x="39" y="5"/>
-                </a:cubicBezTo>
-                <a:cubicBezTo>
-                  <a:pt x="47" y="2"/>
-                  <a:pt x="55" y="0"/>
-                  <a:pt x="63" y="0"/>
-                </a:cubicBezTo>
-                <a:cubicBezTo>
-                  <a:pt x="71" y="0"/>
-                  <a:pt x="79" y="2"/>
-                  <a:pt x="87" y="5"/>
-                </a:cubicBezTo>
-                <a:cubicBezTo>
-                  <a:pt x="95" y="8"/>
-                  <a:pt x="102" y="12"/>
-                  <a:pt x="109" y="18"/>
-                </a:cubicBezTo>
-                <a:cubicBezTo>
-                  <a:pt x="115" y="24"/>
-                  <a:pt x="119" y="31"/>
-                  <a:pt x="122" y="38"/>
-                </a:cubicBezTo>
-                <a:cubicBezTo>
-                  <a:pt x="126" y="46"/>
-                  <a:pt x="127" y="54"/>
-                  <a:pt x="127" y="62"/>
-                </a:cubicBezTo>
-                <a:close/>
-              </a:path>
-            </a:pathLst>
-          </a:custGeom>
-          <a:solidFill>
-            <a:srgbClr val="2a6797"/>
-          </a:solidFill>
-          <a:ln w="0">
-            <a:noFill/>
-          </a:ln>
-        </p:spPr>
-        <p:txBody>
-          <a:bodyPr lIns="0" rIns="0" tIns="0" bIns="0" anchor="t">
-            <a:noAutofit/>
-          </a:bodyPr>
-          <a:p>
-            <a:endParaRPr b="0" lang="en-US" sz="2400" strike="noStrike" u="none">
-              <a:solidFill>
-                <a:srgbClr val="ffffff"/>
-              </a:solidFill>
-              <a:effectLst/>
-              <a:uFillTx/>
-              <a:latin typeface="Times New Roman"/>
-            </a:endParaRPr>
-          </a:p>
-        </p:txBody>
-      </p:sp>
-      <p:sp>
-        <p:nvSpPr>
-          <p:cNvPr id="142" name=""/>
+          <p:cNvPr id="143" name=""/>
           <p:cNvSpPr txBox="1"/>
           <p:nvPr/>
         </p:nvSpPr>
         <p:spPr>
           <a:xfrm>
-            <a:off x="762120" y="3908880"/>
-            <a:ext cx="449280" cy="239760"/>
+            <a:off x="762120" y="4680720"/>
+            <a:ext cx="1130400" cy="597600"/>
+          </a:xfrm>
+          <a:prstGeom prst="rect">
+            <a:avLst/>
+          </a:prstGeom>
+          <a:noFill/>
+          <a:ln w="0">
+            <a:noFill/>
+          </a:ln>
+        </p:spPr>
+        <p:txBody>
+          <a:bodyPr wrap="none" lIns="0" rIns="0" tIns="0" bIns="0" anchor="t">
+            <a:spAutoFit/>
+          </a:bodyPr>
+          <a:p>
+            <a:r>
+              <a:rPr b="1" lang="en-US" sz="4000" strike="noStrike" u="none">
+                <a:solidFill>
+                  <a:srgbClr val="1f2328"/>
+                </a:solidFill>
+                <a:effectLst/>
+                <a:uFillTx/>
+                <a:latin typeface="LucidaGrande"/>
+                <a:ea typeface="LucidaGrande"/>
+              </a:rPr>
+              <a:t>4:00</a:t>
+            </a:r>
+            <a:endParaRPr b="0" lang="en-US" sz="4000" strike="noStrike" u="none">
+              <a:solidFill>
+                <a:srgbClr val="000000"/>
+              </a:solidFill>
+              <a:effectLst/>
+              <a:uFillTx/>
+              <a:latin typeface="Times New Roman"/>
+            </a:endParaRPr>
+          </a:p>
+        </p:txBody>
+      </p:sp>
+      <p:sp>
+        <p:nvSpPr>
+          <p:cNvPr id="144" name=""/>
+          <p:cNvSpPr txBox="1"/>
+          <p:nvPr/>
+        </p:nvSpPr>
+        <p:spPr>
+          <a:xfrm>
+            <a:off x="1994400" y="4975560"/>
+            <a:ext cx="792360" cy="239760"/>
           </a:xfrm>
           <a:prstGeom prst="rect">
             <a:avLst/>
@@ -25278,56 +25372,9 @@
                 <a:latin typeface="LucidaGrande"/>
                 <a:ea typeface="LucidaGrande"/>
               </a:rPr>
-              <a:t>4:00</a:t>
+              <a:t>minutes</a:t>
             </a:r>
             <a:endParaRPr b="0" lang="en-US" sz="1600" strike="noStrike" u="none">
-              <a:solidFill>
-                <a:srgbClr val="000000"/>
-              </a:solidFill>
-              <a:effectLst/>
-              <a:uFillTx/>
-              <a:latin typeface="Times New Roman"/>
-            </a:endParaRPr>
-          </a:p>
-        </p:txBody>
-      </p:sp>
-      <p:sp>
-        <p:nvSpPr>
-          <p:cNvPr id="143" name=""/>
-          <p:cNvSpPr txBox="1"/>
-          <p:nvPr/>
-        </p:nvSpPr>
-        <p:spPr>
-          <a:xfrm>
-            <a:off x="1229040" y="3674160"/>
-            <a:ext cx="3089160" cy="478800"/>
-          </a:xfrm>
-          <a:prstGeom prst="rect">
-            <a:avLst/>
-          </a:prstGeom>
-          <a:noFill/>
-          <a:ln w="0">
-            <a:noFill/>
-          </a:ln>
-        </p:spPr>
-        <p:txBody>
-          <a:bodyPr wrap="none" lIns="0" rIns="0" tIns="0" bIns="0" anchor="t">
-            <a:spAutoFit/>
-          </a:bodyPr>
-          <a:p>
-            <a:r>
-              <a:rPr b="1" lang="en-US" sz="3200" strike="noStrike" u="none">
-                <a:solidFill>
-                  <a:srgbClr val="ffffff"/>
-                </a:solidFill>
-                <a:effectLst/>
-                <a:uFillTx/>
-                <a:latin typeface="LucidaGrande"/>
-                <a:ea typeface="LucidaGrande"/>
-              </a:rPr>
-              <a:t> Turn and Talk</a:t>
-            </a:r>
-            <a:endParaRPr b="0" lang="en-US" sz="3200" strike="noStrike" u="none">
               <a:solidFill>
                 <a:srgbClr val="000000"/>
               </a:solidFill>
@@ -25370,7 +25417,7 @@
       </p:grpSpPr>
       <p:sp>
         <p:nvSpPr>
-          <p:cNvPr id="144" name=""/>
+          <p:cNvPr id="145" name=""/>
           <p:cNvSpPr/>
           <p:nvPr/>
         </p:nvSpPr>
@@ -25430,7 +25477,7 @@
       </p:sp>
       <p:sp>
         <p:nvSpPr>
-          <p:cNvPr id="145" name=""/>
+          <p:cNvPr id="146" name=""/>
           <p:cNvSpPr/>
           <p:nvPr/>
         </p:nvSpPr>
@@ -25490,7 +25537,7 @@
       </p:sp>
       <p:sp>
         <p:nvSpPr>
-          <p:cNvPr id="146" name=""/>
+          <p:cNvPr id="147" name=""/>
           <p:cNvSpPr/>
           <p:nvPr/>
         </p:nvSpPr>
@@ -25550,7 +25597,7 @@
       </p:sp>
       <p:pic>
         <p:nvPicPr>
-          <p:cNvPr id="147" name="" descr=""/>
+          <p:cNvPr id="148" name="" descr=""/>
           <p:cNvPicPr/>
           <p:nvPr/>
         </p:nvPicPr>
@@ -25574,7 +25621,7 @@
       </p:pic>
       <p:sp>
         <p:nvSpPr>
-          <p:cNvPr id="148" name=""/>
+          <p:cNvPr id="149" name=""/>
           <p:cNvSpPr/>
           <p:nvPr/>
         </p:nvSpPr>
@@ -25702,7 +25749,7 @@
       </p:sp>
       <p:sp>
         <p:nvSpPr>
-          <p:cNvPr id="149" name=""/>
+          <p:cNvPr id="150" name=""/>
           <p:cNvSpPr txBox="1"/>
           <p:nvPr/>
         </p:nvSpPr>
@@ -25749,7 +25796,7 @@
       </p:sp>
       <p:sp>
         <p:nvSpPr>
-          <p:cNvPr id="150" name=""/>
+          <p:cNvPr id="151" name=""/>
           <p:cNvSpPr/>
           <p:nvPr/>
         </p:nvSpPr>
@@ -25877,7 +25924,7 @@
       </p:sp>
       <p:sp>
         <p:nvSpPr>
-          <p:cNvPr id="151" name=""/>
+          <p:cNvPr id="152" name=""/>
           <p:cNvSpPr txBox="1"/>
           <p:nvPr/>
         </p:nvSpPr>
@@ -25924,7 +25971,7 @@
       </p:sp>
       <p:sp>
         <p:nvSpPr>
-          <p:cNvPr id="152" name=""/>
+          <p:cNvPr id="153" name=""/>
           <p:cNvSpPr/>
           <p:nvPr/>
         </p:nvSpPr>
@@ -26052,7 +26099,7 @@
       </p:sp>
       <p:sp>
         <p:nvSpPr>
-          <p:cNvPr id="153" name=""/>
+          <p:cNvPr id="154" name=""/>
           <p:cNvSpPr txBox="1"/>
           <p:nvPr/>
         </p:nvSpPr>
@@ -26099,7 +26146,7 @@
       </p:sp>
       <p:sp>
         <p:nvSpPr>
-          <p:cNvPr id="154" name=""/>
+          <p:cNvPr id="155" name=""/>
           <p:cNvSpPr/>
           <p:nvPr/>
         </p:nvSpPr>
@@ -26227,7 +26274,7 @@
       </p:sp>
       <p:sp>
         <p:nvSpPr>
-          <p:cNvPr id="155" name=""/>
+          <p:cNvPr id="156" name=""/>
           <p:cNvSpPr txBox="1"/>
           <p:nvPr/>
         </p:nvSpPr>
@@ -26274,7 +26321,7 @@
       </p:sp>
       <p:sp>
         <p:nvSpPr>
-          <p:cNvPr id="156" name=""/>
+          <p:cNvPr id="157" name=""/>
           <p:cNvSpPr txBox="1"/>
           <p:nvPr/>
         </p:nvSpPr>
@@ -26321,7 +26368,7 @@
       </p:sp>
       <p:sp>
         <p:nvSpPr>
-          <p:cNvPr id="157" name=""/>
+          <p:cNvPr id="158" name=""/>
           <p:cNvSpPr txBox="1"/>
           <p:nvPr/>
         </p:nvSpPr>
@@ -26368,7 +26415,7 @@
       </p:sp>
       <p:sp>
         <p:nvSpPr>
-          <p:cNvPr id="158" name=""/>
+          <p:cNvPr id="159" name=""/>
           <p:cNvSpPr/>
           <p:nvPr/>
         </p:nvSpPr>
@@ -26584,7 +26631,7 @@
       </p:sp>
       <p:sp>
         <p:nvSpPr>
-          <p:cNvPr id="159" name=""/>
+          <p:cNvPr id="160" name=""/>
           <p:cNvSpPr txBox="1"/>
           <p:nvPr/>
         </p:nvSpPr>
@@ -26631,7 +26678,7 @@
       </p:sp>
       <p:sp>
         <p:nvSpPr>
-          <p:cNvPr id="160" name=""/>
+          <p:cNvPr id="161" name=""/>
           <p:cNvSpPr txBox="1"/>
           <p:nvPr/>
         </p:nvSpPr>

</xml_diff>